<commit_message>
docs: refresh all deliverables — 4 sources (NASA POWER, DMC), governance + monitors, all verification URLs
</commit_message>
<xml_diff>
--- a/docs/overview/poc-deck.pptx
+++ b/docs/overview/poc-deck.pptx
@@ -3102,8 +3102,8 @@
         </p:nvSpPr>
         <p:spPr>
           <a:xfrm>
-            <a:off x="548640" y="2194560"/>
-            <a:ext cx="11064240" cy="1188720"/>
+            <a:off x="914400" y="2377440"/>
+            <a:ext cx="10332720" cy="2194560"/>
           </a:xfrm>
           <a:prstGeom prst="rect">
             <a:avLst/>
@@ -3116,8 +3116,8 @@
           </a:bodyPr>
           <a:lstStyle/>
           <a:p>
-            <a:pPr>
-              <a:defRPr sz="4000" b="1">
+            <a:pPr algn="ctr">
+              <a:defRPr sz="4600" b="1">
                 <a:solidFill>
                   <a:srgbClr val="0F172A"/>
                 </a:solidFill>
@@ -3127,74 +3127,28 @@
               <a:t>Renewable-Energy PoC</a:t>
             </a:r>
           </a:p>
-        </p:txBody>
-      </p:sp>
-      <p:sp>
-        <p:nvSpPr>
-          <p:cNvPr id="3" name="TextBox 2"/>
-          <p:cNvSpPr txBox="1"/>
-          <p:nvPr/>
-        </p:nvSpPr>
-        <p:spPr>
-          <a:xfrm>
-            <a:off x="548640" y="3383280"/>
-            <a:ext cx="11064240" cy="731520"/>
-          </a:xfrm>
-          <a:prstGeom prst="rect">
-            <a:avLst/>
-          </a:prstGeom>
-          <a:noFill/>
-        </p:spPr>
-        <p:txBody>
-          <a:bodyPr wrap="square">
-            <a:spAutoFit/>
-          </a:bodyPr>
-          <a:lstStyle/>
-          <a:p>
-            <a:pPr>
-              <a:defRPr sz="1800" b="0">
+          <a:p>
+            <a:pPr algn="ctr">
+              <a:defRPr sz="2200">
+                <a:solidFill>
+                  <a:srgbClr val="0284C7"/>
+                </a:solidFill>
+              </a:defRPr>
+            </a:pPr>
+            <a:r>
+              <a:t>Chilean renewable-energy medallion on Databricks</a:t>
+            </a:r>
+          </a:p>
+          <a:p>
+            <a:pPr algn="ctr">
+              <a:defRPr sz="1400" i="1">
                 <a:solidFill>
                   <a:srgbClr val="64748B"/>
                 </a:solidFill>
               </a:defRPr>
             </a:pPr>
             <a:r>
-              <a:t>Weather streaming solution on Databricks  -  DGF API -&gt; Volume -&gt; Medallion -&gt; Gold</a:t>
-            </a:r>
-          </a:p>
-        </p:txBody>
-      </p:sp>
-      <p:sp>
-        <p:nvSpPr>
-          <p:cNvPr id="4" name="TextBox 3"/>
-          <p:cNvSpPr txBox="1"/>
-          <p:nvPr/>
-        </p:nvSpPr>
-        <p:spPr>
-          <a:xfrm>
-            <a:off x="548640" y="4023360"/>
-            <a:ext cx="11064240" cy="457200"/>
-          </a:xfrm>
-          <a:prstGeom prst="rect">
-            <a:avLst/>
-          </a:prstGeom>
-          <a:noFill/>
-        </p:spPr>
-        <p:txBody>
-          <a:bodyPr wrap="square">
-            <a:spAutoFit/>
-          </a:bodyPr>
-          <a:lstStyle/>
-          <a:p>
-            <a:pPr>
-              <a:defRPr sz="1400" b="0">
-                <a:solidFill>
-                  <a:srgbClr val="64748B"/>
-                </a:solidFill>
-              </a:defRPr>
-            </a:pPr>
-            <a:r>
-              <a:t>2026-07-02</a:t>
+              <a:t>4 data sources - 3 domains - governed &amp; monitored - dev  |  2026-07-17</a:t>
             </a:r>
           </a:p>
         </p:txBody>
@@ -3225,7 +3179,7 @@
         </p:nvSpPr>
         <p:spPr>
           <a:xfrm>
-            <a:off x="548640" y="411480"/>
+            <a:off x="548640" y="365760"/>
             <a:ext cx="11064240" cy="914400"/>
           </a:xfrm>
           <a:prstGeom prst="rect">
@@ -3240,14 +3194,26 @@
           <a:lstStyle/>
           <a:p>
             <a:pPr>
-              <a:defRPr sz="2800" b="1">
-                <a:solidFill>
-                  <a:srgbClr val="0F766E"/>
+              <a:defRPr sz="3000" b="1">
+                <a:solidFill>
+                  <a:srgbClr val="0284C7"/>
                 </a:solidFill>
               </a:defRPr>
             </a:pPr>
             <a:r>
-              <a:t>Overview</a:t>
+              <a:t>Four data sources - all real data</a:t>
+            </a:r>
+          </a:p>
+          <a:p>
+            <a:pPr>
+              <a:defRPr sz="1300" i="1">
+                <a:solidFill>
+                  <a:srgbClr val="64748B"/>
+                </a:solidFill>
+              </a:defRPr>
+            </a:pPr>
+            <a:r>
+              <a:t>The ingestion layer</a:t>
             </a:r>
           </a:p>
         </p:txBody>
@@ -3261,7 +3227,7 @@
         <p:spPr>
           <a:xfrm>
             <a:off x="640080" y="1554480"/>
-            <a:ext cx="10972800" cy="4937760"/>
+            <a:ext cx="10881360" cy="4937760"/>
           </a:xfrm>
           <a:prstGeom prst="rect">
             <a:avLst/>
@@ -3276,46 +3242,76 @@
           <a:p>
             <a:pPr>
               <a:spcAft>
-                <a:spcPts val="1200"/>
+                <a:spcPts val="600"/>
               </a:spcAft>
               <a:defRPr sz="1800">
                 <a:solidFill>
-                  <a:srgbClr val="334155"/>
+                  <a:srgbClr val="0F172A"/>
                 </a:solidFill>
               </a:defRPr>
             </a:pPr>
             <a:r>
-              <a:t>•  Proof of concept: a renewable-energy data platform on Databricks (medallion bronze -&gt; silver -&gt; gold).</a:t>
+              <a:t>Weather: NASA POWER (historical hourly) + DMC (real-time measured) + MinEnergia/DGF (modeled)</a:t>
             </a:r>
           </a:p>
           <a:p>
             <a:pPr>
               <a:spcAft>
-                <a:spcPts val="1200"/>
+                <a:spcPts val="600"/>
               </a:spcAft>
               <a:defRPr sz="1800">
                 <a:solidFill>
-                  <a:srgbClr val="334155"/>
+                  <a:srgbClr val="0F172A"/>
                 </a:solidFill>
               </a:defRPr>
             </a:pPr>
             <a:r>
-              <a:t>•  Ingests REAL data from the data owner (DGF, U. de Chile Geophysics) and turns it into analytics-ready metrics.</a:t>
+              <a:t>Resource (generation): CEN / Coordinador - PUBLIC by law, no cost, no registration</a:t>
             </a:r>
           </a:p>
           <a:p>
             <a:pPr>
               <a:spcAft>
-                <a:spcPts val="1200"/>
+                <a:spcPts val="600"/>
               </a:spcAft>
               <a:defRPr sz="1800">
                 <a:solidFill>
-                  <a:srgbClr val="334155"/>
+                  <a:srgbClr val="0F172A"/>
                 </a:solidFill>
               </a:defRPr>
             </a:pPr>
             <a:r>
-              <a:t>•  Fully automated (hourly) and governed - Databricks-native (Unity Catalog + DLT).</a:t>
+              <a:t>Conglomerate (country): Our World in Data (OWID) - open CSV</a:t>
+            </a:r>
+          </a:p>
+          <a:p>
+            <a:pPr>
+              <a:spcAft>
+                <a:spcPts val="600"/>
+              </a:spcAft>
+              <a:defRPr sz="1800">
+                <a:solidFill>
+                  <a:srgbClr val="0F172A"/>
+                </a:solidFill>
+              </a:defRPr>
+            </a:pPr>
+            <a:r>
+              <a:t>Key unblock: CEN reachable via the public key its own site exposes</a:t>
+            </a:r>
+          </a:p>
+          <a:p>
+            <a:pPr>
+              <a:spcAft>
+                <a:spcPts val="600"/>
+              </a:spcAft>
+              <a:defRPr sz="1800">
+                <a:solidFill>
+                  <a:srgbClr val="0F172A"/>
+                </a:solidFill>
+              </a:defRPr>
+            </a:pPr>
+            <a:r>
+              <a:t>Key unblock: NASA POWER = 10-year hourly historical, DMC-equivalent fields</a:t>
             </a:r>
           </a:p>
         </p:txBody>
@@ -3346,8 +3342,8 @@
         </p:nvSpPr>
         <p:spPr>
           <a:xfrm>
-            <a:off x="548640" y="411480"/>
-            <a:ext cx="11064240" cy="914400"/>
+            <a:off x="548640" y="274320"/>
+            <a:ext cx="11064240" cy="731520"/>
           </a:xfrm>
           <a:prstGeom prst="rect">
             <a:avLst/>
@@ -3355,20 +3351,20 @@
           <a:noFill/>
         </p:spPr>
         <p:txBody>
-          <a:bodyPr wrap="square">
+          <a:bodyPr wrap="none">
             <a:spAutoFit/>
           </a:bodyPr>
           <a:lstStyle/>
           <a:p>
             <a:pPr>
-              <a:defRPr sz="2800" b="1">
-                <a:solidFill>
-                  <a:srgbClr val="0F766E"/>
+              <a:defRPr sz="2600" b="1">
+                <a:solidFill>
+                  <a:srgbClr val="0284C7"/>
                 </a:solidFill>
               </a:defRPr>
             </a:pPr>
             <a:r>
-              <a:t>Architecture (Medallion)</a:t>
+              <a:t>Architecture (medallion on Databricks)</a:t>
             </a:r>
           </a:p>
         </p:txBody>
@@ -3389,8 +3385,8 @@
         </p:blipFill>
         <p:spPr>
           <a:xfrm>
-            <a:off x="457200" y="2011680"/>
-            <a:ext cx="11247120" cy="3698717"/>
+            <a:off x="457200" y="1143000"/>
+            <a:ext cx="11247120" cy="6351825"/>
           </a:xfrm>
           <a:prstGeom prst="rect">
             <a:avLst/>
@@ -3423,8 +3419,8 @@
         </p:nvSpPr>
         <p:spPr>
           <a:xfrm>
-            <a:off x="548640" y="411480"/>
-            <a:ext cx="11064240" cy="914400"/>
+            <a:off x="548640" y="274320"/>
+            <a:ext cx="11064240" cy="731520"/>
           </a:xfrm>
           <a:prstGeom prst="rect">
             <a:avLst/>
@@ -3432,122 +3428,48 @@
           <a:noFill/>
         </p:spPr>
         <p:txBody>
-          <a:bodyPr wrap="square">
+          <a:bodyPr wrap="none">
             <a:spAutoFit/>
           </a:bodyPr>
           <a:lstStyle/>
           <a:p>
             <a:pPr>
-              <a:defRPr sz="2800" b="1">
-                <a:solidFill>
-                  <a:srgbClr val="0F766E"/>
+              <a:defRPr sz="2600" b="1">
+                <a:solidFill>
+                  <a:srgbClr val="0284C7"/>
                 </a:solidFill>
               </a:defRPr>
             </a:pPr>
             <a:r>
-              <a:t>Weather streaming solution (end-to-end)</a:t>
-            </a:r>
-          </a:p>
-        </p:txBody>
-      </p:sp>
-      <p:sp>
-        <p:nvSpPr>
-          <p:cNvPr id="3" name="TextBox 2"/>
-          <p:cNvSpPr txBox="1"/>
+              <a:t>End-to-end workflow</a:t>
+            </a:r>
+          </a:p>
+        </p:txBody>
+      </p:sp>
+      <p:pic>
+        <p:nvPicPr>
+          <p:cNvPr id="3" name="Picture 2" descr="workflow.png"/>
+          <p:cNvPicPr>
+            <a:picLocks noChangeAspect="1"/>
+          </p:cNvPicPr>
           <p:nvPr/>
-        </p:nvSpPr>
+        </p:nvPicPr>
+        <p:blipFill>
+          <a:blip r:embed="rId2"/>
+          <a:stretch>
+            <a:fillRect/>
+          </a:stretch>
+        </p:blipFill>
         <p:spPr>
           <a:xfrm>
-            <a:off x="640080" y="1554480"/>
-            <a:ext cx="10972800" cy="4937760"/>
+            <a:off x="457200" y="1143000"/>
+            <a:ext cx="11247120" cy="6211960"/>
           </a:xfrm>
           <a:prstGeom prst="rect">
             <a:avLst/>
           </a:prstGeom>
-          <a:noFill/>
         </p:spPr>
-        <p:txBody>
-          <a:bodyPr wrap="square">
-            <a:spAutoFit/>
-          </a:bodyPr>
-          <a:lstStyle/>
-          <a:p>
-            <a:pPr>
-              <a:spcAft>
-                <a:spcPts val="1200"/>
-              </a:spcAft>
-              <a:defRPr sz="1800">
-                <a:solidFill>
-                  <a:srgbClr val="334155"/>
-                </a:solidFill>
-              </a:defRPr>
-            </a:pPr>
-            <a:r>
-              <a:t>•  API -&gt; Volume: fetcher hits the open DGF Explorador (no login), lands JSON in a UC Volume.</a:t>
-            </a:r>
-          </a:p>
-          <a:p>
-            <a:pPr>
-              <a:spcAft>
-                <a:spcPts val="1200"/>
-              </a:spcAft>
-              <a:defRPr sz="1800">
-                <a:solidFill>
-                  <a:srgbClr val="334155"/>
-                </a:solidFill>
-              </a:defRPr>
-            </a:pPr>
-            <a:r>
-              <a:t>•  Bronze: Auto Loader (streaming) ingests the Volume - raw + lineage.</a:t>
-            </a:r>
-          </a:p>
-          <a:p>
-            <a:pPr>
-              <a:spcAft>
-                <a:spcPts val="1200"/>
-              </a:spcAft>
-              <a:defRPr sz="1800">
-                <a:solidFill>
-                  <a:srgbClr val="334155"/>
-                </a:solidFill>
-              </a:defRPr>
-            </a:pPr>
-            <a:r>
-              <a:t>•  Silver: flatten + latest-per-plant + data quality (DLT expectations).</a:t>
-            </a:r>
-          </a:p>
-          <a:p>
-            <a:pPr>
-              <a:spcAft>
-                <a:spcPts val="1200"/>
-              </a:spcAft>
-              <a:defRPr sz="1800">
-                <a:solidFill>
-                  <a:srgbClr val="334155"/>
-                </a:solidFill>
-              </a:defRPr>
-            </a:pPr>
-            <a:r>
-              <a:t>•  Gold: per-plant resource KPI (metric, rank, A/B/C tier).</a:t>
-            </a:r>
-          </a:p>
-          <a:p>
-            <a:pPr>
-              <a:spcAft>
-                <a:spcPts val="1200"/>
-              </a:spcAft>
-              <a:defRPr sz="1800">
-                <a:solidFill>
-                  <a:srgbClr val="334155"/>
-                </a:solidFill>
-              </a:defRPr>
-            </a:pPr>
-            <a:r>
-              <a:t>•  Orchestration: hourly Job  fetch_weather -&gt; weather_medallion (DLT).</a:t>
-            </a:r>
-          </a:p>
-        </p:txBody>
-      </p:sp>
+      </p:pic>
     </p:spTree>
   </p:cSld>
   <p:clrMapOvr>
@@ -3574,7 +3496,7 @@
         </p:nvSpPr>
         <p:spPr>
           <a:xfrm>
-            <a:off x="548640" y="411480"/>
+            <a:off x="548640" y="365760"/>
             <a:ext cx="11064240" cy="914400"/>
           </a:xfrm>
           <a:prstGeom prst="rect">
@@ -3589,9 +3511,9 @@
           <a:lstStyle/>
           <a:p>
             <a:pPr>
-              <a:defRPr sz="2800" b="1">
-                <a:solidFill>
-                  <a:srgbClr val="0F766E"/>
+              <a:defRPr sz="3000" b="1">
+                <a:solidFill>
+                  <a:srgbClr val="059669"/>
                 </a:solidFill>
               </a:defRPr>
             </a:pPr>
@@ -3610,7 +3532,7 @@
         <p:spPr>
           <a:xfrm>
             <a:off x="640080" y="1554480"/>
-            <a:ext cx="10972800" cy="4937760"/>
+            <a:ext cx="10881360" cy="4937760"/>
           </a:xfrm>
           <a:prstGeom prst="rect">
             <a:avLst/>
@@ -3625,61 +3547,61 @@
           <a:p>
             <a:pPr>
               <a:spcAft>
-                <a:spcPts val="1200"/>
+                <a:spcPts val="600"/>
               </a:spcAft>
               <a:defRPr sz="1800">
                 <a:solidFill>
-                  <a:srgbClr val="334155"/>
+                  <a:srgbClr val="0F172A"/>
                 </a:solidFill>
               </a:defRPr>
             </a:pPr>
             <a:r>
-              <a:t>•  Job runs end-to-end (fetch + medallion) on REAL data for 10 Chilean plants.</a:t>
+              <a:t>Medallion runs end-to-end for all three domains (bronze -&gt; silver -&gt; gold)</a:t>
             </a:r>
           </a:p>
           <a:p>
             <a:pPr>
               <a:spcAft>
-                <a:spcPts val="1200"/>
+                <a:spcPts val="600"/>
               </a:spcAft>
               <a:defRPr sz="1800">
                 <a:solidFill>
-                  <a:srgbClr val="334155"/>
+                  <a:srgbClr val="0F172A"/>
                 </a:solidFill>
               </a:defRPr>
             </a:pPr>
             <a:r>
-              <a:t>•  Gold: 5 solar + 5 wind plants, ranked by resource with a quality tier.</a:t>
+              <a:t>Weather: 876,720-row 10-year historical load; Atacama shows highest irradiance (physically valid)</a:t>
             </a:r>
           </a:p>
           <a:p>
             <a:pPr>
               <a:spcAft>
-                <a:spcPts val="1200"/>
+                <a:spcPts val="600"/>
               </a:spcAft>
               <a:defRPr sz="1800">
                 <a:solidFill>
-                  <a:srgbClr val="334155"/>
+                  <a:srgbClr val="0F172A"/>
                 </a:solidFill>
               </a:defRPr>
             </a:pPr>
             <a:r>
-              <a:t>•  Solar (GHI): Cerro Dominador 7.28 (A), Bolero 7.18 (A) ... Quilapilun 5.75 (B).</a:t>
+              <a:t>Resource: real per-plant generation (coordinado / real / reducciones)</a:t>
             </a:r>
           </a:p>
           <a:p>
             <a:pPr>
               <a:spcAft>
-                <a:spcPts val="1200"/>
+                <a:spcPts val="600"/>
               </a:spcAft>
               <a:defRPr sz="1800">
                 <a:solidFill>
-                  <a:srgbClr val="334155"/>
+                  <a:srgbClr val="0F172A"/>
                 </a:solidFill>
               </a:defRPr>
             </a:pPr>
             <a:r>
-              <a:t>•  Wind (m/s): Negrete Cuel 7.85 (A), El Arrayan 6.02 (B) ... Canela 3.62 (C).</a:t>
+              <a:t>Conglomerate: Chile-vs-World renewables lead +19 -&gt; +38 (2017-2024)</a:t>
             </a:r>
           </a:p>
         </p:txBody>
@@ -3710,7 +3632,7 @@
         </p:nvSpPr>
         <p:spPr>
           <a:xfrm>
-            <a:off x="548640" y="411480"/>
+            <a:off x="548640" y="365760"/>
             <a:ext cx="11064240" cy="914400"/>
           </a:xfrm>
           <a:prstGeom prst="rect">
@@ -3725,14 +3647,14 @@
           <a:lstStyle/>
           <a:p>
             <a:pPr>
-              <a:defRPr sz="2800" b="1">
-                <a:solidFill>
-                  <a:srgbClr val="0F766E"/>
+              <a:defRPr sz="3000" b="1">
+                <a:solidFill>
+                  <a:srgbClr val="0284C7"/>
                 </a:solidFill>
               </a:defRPr>
             </a:pPr>
             <a:r>
-              <a:t>Governance &amp; data quality (Databricks-native)</a:t>
+              <a:t>Governance &amp; data quality (native)</a:t>
             </a:r>
           </a:p>
         </p:txBody>
@@ -3746,7 +3668,7 @@
         <p:spPr>
           <a:xfrm>
             <a:off x="640080" y="1554480"/>
-            <a:ext cx="10972800" cy="4937760"/>
+            <a:ext cx="10881360" cy="4937760"/>
           </a:xfrm>
           <a:prstGeom prst="rect">
             <a:avLst/>
@@ -3761,61 +3683,76 @@
           <a:p>
             <a:pPr>
               <a:spcAft>
-                <a:spcPts val="1200"/>
+                <a:spcPts val="600"/>
               </a:spcAft>
               <a:defRPr sz="1800">
                 <a:solidFill>
-                  <a:srgbClr val="334155"/>
+                  <a:srgbClr val="0F172A"/>
                 </a:solidFill>
               </a:defRPr>
             </a:pPr>
             <a:r>
-              <a:t>•  Data quality / contracts: DLT expectations (event log) + Unity Catalog constraints.</a:t>
+              <a:t>Data contracts documented for every medallion step</a:t>
             </a:r>
           </a:p>
           <a:p>
             <a:pPr>
               <a:spcAft>
-                <a:spcPts val="1200"/>
+                <a:spcPts val="600"/>
               </a:spcAft>
               <a:defRPr sz="1800">
                 <a:solidFill>
-                  <a:srgbClr val="334155"/>
+                  <a:srgbClr val="0F172A"/>
                 </a:solidFill>
               </a:defRPr>
             </a:pPr>
             <a:r>
-              <a:t>•  Lineage: Unity Catalog - automatic table + column lineage.</a:t>
+              <a:t>DLT expectations enforce quality in-pipeline</a:t>
             </a:r>
           </a:p>
           <a:p>
             <a:pPr>
               <a:spcAft>
-                <a:spcPts val="1200"/>
+                <a:spcPts val="600"/>
               </a:spcAft>
               <a:defRPr sz="1800">
                 <a:solidFill>
-                  <a:srgbClr val="334155"/>
+                  <a:srgbClr val="0F172A"/>
                 </a:solidFill>
               </a:defRPr>
             </a:pPr>
             <a:r>
-              <a:t>•  Glossary: UC tags + column comments (100% documented).</a:t>
+              <a:t>Data glossary + Unity Catalog lineage + column comments</a:t>
             </a:r>
           </a:p>
           <a:p>
             <a:pPr>
               <a:spcAft>
-                <a:spcPts val="1200"/>
+                <a:spcPts val="600"/>
               </a:spcAft>
               <a:defRPr sz="1800">
                 <a:solidFill>
-                  <a:srgbClr val="334155"/>
+                  <a:srgbClr val="0F172A"/>
                 </a:solidFill>
               </a:defRPr>
             </a:pPr>
             <a:r>
-              <a:t>•  No external tools required (OpenMetadata / Great Expectations not needed).</a:t>
+              <a:t>Three Data-Quality Monitors on gold (profiling + drift, auto dashboards)</a:t>
+            </a:r>
+          </a:p>
+          <a:p>
+            <a:pPr>
+              <a:spcAft>
+                <a:spcPts val="600"/>
+              </a:spcAft>
+              <a:defRPr sz="1800">
+                <a:solidFill>
+                  <a:srgbClr val="0F172A"/>
+                </a:solidFill>
+              </a:defRPr>
+            </a:pPr>
+            <a:r>
+              <a:t>SQL alert on failed expectations</a:t>
             </a:r>
           </a:p>
         </p:txBody>
@@ -3846,7 +3783,7 @@
         </p:nvSpPr>
         <p:spPr>
           <a:xfrm>
-            <a:off x="548640" y="411480"/>
+            <a:off x="548640" y="365760"/>
             <a:ext cx="11064240" cy="914400"/>
           </a:xfrm>
           <a:prstGeom prst="rect">
@@ -3861,14 +3798,26 @@
           <a:lstStyle/>
           <a:p>
             <a:pPr>
-              <a:defRPr sz="2800" b="1">
-                <a:solidFill>
-                  <a:srgbClr val="0F766E"/>
+              <a:defRPr sz="3000" b="1">
+                <a:solidFill>
+                  <a:srgbClr val="64748B"/>
                 </a:solidFill>
               </a:defRPr>
             </a:pPr>
             <a:r>
-              <a:t>Status, next steps &amp; links</a:t>
+              <a:t>Verify the medallion &amp; jobs</a:t>
+            </a:r>
+          </a:p>
+          <a:p>
+            <a:pPr>
+              <a:defRPr sz="1300" i="1">
+                <a:solidFill>
+                  <a:srgbClr val="64748B"/>
+                </a:solidFill>
+              </a:defRPr>
+            </a:pPr>
+            <a:r>
+              <a:t>Full URLs in the technical documentation</a:t>
             </a:r>
           </a:p>
         </p:txBody>
@@ -3882,7 +3831,7 @@
         <p:spPr>
           <a:xfrm>
             <a:off x="640080" y="1554480"/>
-            <a:ext cx="10972800" cy="4937760"/>
+            <a:ext cx="10881360" cy="4937760"/>
           </a:xfrm>
           <a:prstGeom prst="rect">
             <a:avLst/>
@@ -3897,114 +3846,91 @@
           <a:p>
             <a:pPr>
               <a:spcAft>
-                <a:spcPts val="1200"/>
+                <a:spcPts val="600"/>
               </a:spcAft>
               <a:defRPr sz="1800">
                 <a:solidFill>
-                  <a:srgbClr val="334155"/>
+                  <a:srgbClr val="0F172A"/>
                 </a:solidFill>
               </a:defRPr>
             </a:pPr>
             <a:r>
-              <a:t>•  Delivered + verified in dev. Pending: review + merge (PR #24) -&gt; deploy to prod (activates the hourly schedule).</a:t>
+              <a:t>Resource pipeline: dbc-...cloud.databricks.com/pipelines/9bcfc32a-...</a:t>
             </a:r>
           </a:p>
           <a:p>
             <a:pPr>
               <a:spcAft>
-                <a:spcPts val="1200"/>
+                <a:spcPts val="600"/>
               </a:spcAft>
               <a:defRPr sz="1800">
                 <a:solidFill>
-                  <a:srgbClr val="334155"/>
+                  <a:srgbClr val="0F172A"/>
                 </a:solidFill>
               </a:defRPr>
             </a:pPr>
             <a:r>
-              <a:t>•  Gated official API (api.minenergia.cl): drop-in source swap once approved; the open Explorador already gives real data.</a:t>
-            </a:r>
-          </a:p>
-        </p:txBody>
-      </p:sp>
-      <p:sp>
-        <p:nvSpPr>
-          <p:cNvPr id="4" name="TextBox 3"/>
-          <p:cNvSpPr txBox="1"/>
-          <p:nvPr/>
-        </p:nvSpPr>
-        <p:spPr>
-          <a:xfrm>
-            <a:off x="640080" y="4023360"/>
-            <a:ext cx="10972800" cy="2377440"/>
-          </a:xfrm>
-          <a:prstGeom prst="rect">
-            <a:avLst/>
-          </a:prstGeom>
-          <a:noFill/>
-        </p:spPr>
-        <p:txBody>
-          <a:bodyPr wrap="square">
-            <a:spAutoFit/>
-          </a:bodyPr>
-          <a:lstStyle/>
+              <a:t>Conglomerate pipeline: .../pipelines/b5d63282-...</a:t>
+            </a:r>
+          </a:p>
           <a:p>
             <a:pPr>
-              <a:defRPr sz="1600" b="1">
+              <a:spcAft>
+                <a:spcPts val="600"/>
+              </a:spcAft>
+              <a:defRPr sz="1800">
                 <a:solidFill>
                   <a:srgbClr val="0F172A"/>
                 </a:solidFill>
               </a:defRPr>
             </a:pPr>
             <a:r>
-              <a:t>Explore / test:</a:t>
+              <a:t>Weather pipeline: .../pipelines/c108b287-...</a:t>
             </a:r>
           </a:p>
           <a:p>
             <a:pPr>
-              <a:defRPr sz="1100">
-                <a:solidFill>
-                  <a:srgbClr val="2563EB"/>
+              <a:spcAft>
+                <a:spcPts val="600"/>
+              </a:spcAft>
+              <a:defRPr sz="1800">
+                <a:solidFill>
+                  <a:srgbClr val="0F172A"/>
                 </a:solidFill>
               </a:defRPr>
             </a:pPr>
             <a:r>
-              <a:t>Job: https://dbc-54b27bae-2e91.cloud.databricks.com/jobs/503330163541320?o=7474645896934260</a:t>
+              <a:t>Weather job: .../jobs/503330163541320</a:t>
             </a:r>
           </a:p>
           <a:p>
             <a:pPr>
-              <a:defRPr sz="1100">
-                <a:solidFill>
-                  <a:srgbClr val="2563EB"/>
+              <a:spcAft>
+                <a:spcPts val="600"/>
+              </a:spcAft>
+              <a:defRPr sz="1800">
+                <a:solidFill>
+                  <a:srgbClr val="0F172A"/>
                 </a:solidFill>
               </a:defRPr>
             </a:pPr>
             <a:r>
-              <a:t>Pipeline: https://dbc-54b27bae-2e91.cloud.databricks.com/pipelines/c108b287-98cc-43d6-86d6-5b63a9e6b4ae?o=7474645896934260</a:t>
+              <a:t>Quality monitor (Resource gold): .../sql/dashboardsv3/01f1809adb1a...</a:t>
             </a:r>
           </a:p>
           <a:p>
             <a:pPr>
-              <a:defRPr sz="1100">
-                <a:solidFill>
-                  <a:srgbClr val="2563EB"/>
+              <a:spcAft>
+                <a:spcPts val="600"/>
+              </a:spcAft>
+              <a:defRPr sz="1800">
+                <a:solidFill>
+                  <a:srgbClr val="0F172A"/>
                 </a:solidFill>
               </a:defRPr>
             </a:pPr>
             <a:r>
-              <a:t>Gold table: https://dbc-54b27bae-2e91.cloud.databricks.com/explore/data/workspace/dev_fuad_onate_renewable_gold_energy_chile/weather_gold_resource_kpi?o=7474645896934260</a:t>
-            </a:r>
-          </a:p>
-          <a:p>
-            <a:pPr>
-              <a:defRPr sz="1100">
-                <a:solidFill>
-                  <a:srgbClr val="2563EB"/>
-                </a:solidFill>
-              </a:defRPr>
-            </a:pPr>
-            <a:r>
-              <a:t>PR #24: https://github.com/oxiboy/poc_databricks_evalueserve/pull/24</a:t>
+              <a:t>Pull requests: github.com/oxiboy/poc_databricks_evalueserve/pulls</a:t>
             </a:r>
           </a:p>
         </p:txBody>

</xml_diff>

<commit_message>
docs: refresh deliverables — weather NASA star schema + marts + AI/BI dashboard (time series & KPIs)
</commit_message>
<xml_diff>
--- a/docs/overview/poc-deck.pptx
+++ b/docs/overview/poc-deck.pptx
@@ -3148,7 +3148,7 @@
               </a:defRPr>
             </a:pPr>
             <a:r>
-              <a:t>4 data sources - 3 domains - governed &amp; monitored - dev  |  2026-07-17</a:t>
+              <a:t>4 data sources - 3 domains - governed, monitored, dashboarded - dev  |  2026-07-21</a:t>
             </a:r>
           </a:p>
         </p:txBody>
@@ -3251,7 +3251,7 @@
               </a:defRPr>
             </a:pPr>
             <a:r>
-              <a:t>Weather: NASA POWER (historical hourly) + DMC (real-time measured) + MinEnergia/DGF (modeled)</a:t>
+              <a:t>Weather: NASA POWER (historical) + DMC (real-time) + MinEnergia/DGF (modeled)</a:t>
             </a:r>
           </a:p>
           <a:p>
@@ -3266,7 +3266,7 @@
               </a:defRPr>
             </a:pPr>
             <a:r>
-              <a:t>Resource (generation): CEN / Coordinador - PUBLIC by law, no cost, no registration</a:t>
+              <a:t>Resource (generation): CEN - public by law, no cost</a:t>
             </a:r>
           </a:p>
           <a:p>
@@ -3281,37 +3281,7 @@
               </a:defRPr>
             </a:pPr>
             <a:r>
-              <a:t>Conglomerate (country): Our World in Data (OWID) - open CSV</a:t>
-            </a:r>
-          </a:p>
-          <a:p>
-            <a:pPr>
-              <a:spcAft>
-                <a:spcPts val="600"/>
-              </a:spcAft>
-              <a:defRPr sz="1800">
-                <a:solidFill>
-                  <a:srgbClr val="0F172A"/>
-                </a:solidFill>
-              </a:defRPr>
-            </a:pPr>
-            <a:r>
-              <a:t>Key unblock: CEN reachable via the public key its own site exposes</a:t>
-            </a:r>
-          </a:p>
-          <a:p>
-            <a:pPr>
-              <a:spcAft>
-                <a:spcPts val="600"/>
-              </a:spcAft>
-              <a:defRPr sz="1800">
-                <a:solidFill>
-                  <a:srgbClr val="0F172A"/>
-                </a:solidFill>
-              </a:defRPr>
-            </a:pPr>
-            <a:r>
-              <a:t>Key unblock: NASA POWER = 10-year hourly historical, DMC-equivalent fields</a:t>
+              <a:t>Conglomerate (country): OWID - open CSV</a:t>
             </a:r>
           </a:p>
         </p:txBody>
@@ -3518,7 +3488,7 @@
               </a:defRPr>
             </a:pPr>
             <a:r>
-              <a:t>Results (verified in dev)</a:t>
+              <a:t>Weather NASA - star schema + marts + dashboard</a:t>
             </a:r>
           </a:p>
         </p:txBody>
@@ -3556,7 +3526,7 @@
               </a:defRPr>
             </a:pPr>
             <a:r>
-              <a:t>Medallion runs end-to-end for all three domains (bronze -&gt; silver -&gt; gold)</a:t>
+              <a:t>Silver STAR: dim_plant + fact_weather_hourly (876,720 rows, 10 years, DQ)</a:t>
             </a:r>
           </a:p>
           <a:p>
@@ -3571,7 +3541,7 @@
               </a:defRPr>
             </a:pPr>
             <a:r>
-              <a:t>Weather: 876,720-row 10-year historical load; Atacama shows highest irradiance (physically valid)</a:t>
+              <a:t>Gold marts: resource KPI + daily (36,530) + monthly (1,200)</a:t>
             </a:r>
           </a:p>
           <a:p>
@@ -3586,7 +3556,7 @@
               </a:defRPr>
             </a:pPr>
             <a:r>
-              <a:t>Resource: real per-plant generation (coordinado / real / reducciones)</a:t>
+              <a:t>AI/BI dashboard: monthly GHI/wind per plant + KPI table</a:t>
             </a:r>
           </a:p>
           <a:p>
@@ -3601,7 +3571,7 @@
               </a:defRPr>
             </a:pPr>
             <a:r>
-              <a:t>Conglomerate: Chile-vs-World renewables lead +19 -&gt; +38 (2017-2024)</a:t>
+              <a:t>Reproducible as DLT pipeline weather_nasa (bundle validate OK)</a:t>
             </a:r>
           </a:p>
         </p:txBody>
@@ -3649,12 +3619,12 @@
             <a:pPr>
               <a:defRPr sz="3000" b="1">
                 <a:solidFill>
-                  <a:srgbClr val="0284C7"/>
+                  <a:srgbClr val="059669"/>
                 </a:solidFill>
               </a:defRPr>
             </a:pPr>
             <a:r>
-              <a:t>Governance &amp; data quality (native)</a:t>
+              <a:t>Results (verified in dev)</a:t>
             </a:r>
           </a:p>
         </p:txBody>
@@ -3692,7 +3662,7 @@
               </a:defRPr>
             </a:pPr>
             <a:r>
-              <a:t>Data contracts documented for every medallion step</a:t>
+              <a:t>Medallion end-to-end for all three domains</a:t>
             </a:r>
           </a:p>
           <a:p>
@@ -3707,7 +3677,7 @@
               </a:defRPr>
             </a:pPr>
             <a:r>
-              <a:t>DLT expectations enforce quality in-pipeline</a:t>
+              <a:t>Weather: 876,720-row 10-year load; Atacama highest irradiance (valid)</a:t>
             </a:r>
           </a:p>
           <a:p>
@@ -3722,7 +3692,7 @@
               </a:defRPr>
             </a:pPr>
             <a:r>
-              <a:t>Data glossary + Unity Catalog lineage + column comments</a:t>
+              <a:t>Resource: real per-plant generation (coord/real/reduc)</a:t>
             </a:r>
           </a:p>
           <a:p>
@@ -3737,22 +3707,7 @@
               </a:defRPr>
             </a:pPr>
             <a:r>
-              <a:t>Three Data-Quality Monitors on gold (profiling + drift, auto dashboards)</a:t>
-            </a:r>
-          </a:p>
-          <a:p>
-            <a:pPr>
-              <a:spcAft>
-                <a:spcPts val="600"/>
-              </a:spcAft>
-              <a:defRPr sz="1800">
-                <a:solidFill>
-                  <a:srgbClr val="0F172A"/>
-                </a:solidFill>
-              </a:defRPr>
-            </a:pPr>
-            <a:r>
-              <a:t>SQL alert on failed expectations</a:t>
+              <a:t>Conglomerate: Chile-vs-World renewables lead +19 -&gt; +38 (2017-2024)</a:t>
             </a:r>
           </a:p>
         </p:txBody>
@@ -3800,24 +3755,12 @@
             <a:pPr>
               <a:defRPr sz="3000" b="1">
                 <a:solidFill>
-                  <a:srgbClr val="64748B"/>
+                  <a:srgbClr val="0284C7"/>
                 </a:solidFill>
               </a:defRPr>
             </a:pPr>
             <a:r>
-              <a:t>Verify the medallion &amp; jobs</a:t>
-            </a:r>
-          </a:p>
-          <a:p>
-            <a:pPr>
-              <a:defRPr sz="1300" i="1">
-                <a:solidFill>
-                  <a:srgbClr val="64748B"/>
-                </a:solidFill>
-              </a:defRPr>
-            </a:pPr>
-            <a:r>
-              <a:t>Full URLs in the technical documentation</a:t>
+              <a:t>Governance, quality &amp; observability</a:t>
             </a:r>
           </a:p>
         </p:txBody>
@@ -3855,7 +3798,7 @@
               </a:defRPr>
             </a:pPr>
             <a:r>
-              <a:t>Resource pipeline: dbc-...cloud.databricks.com/pipelines/9bcfc32a-...</a:t>
+              <a:t>Data contracts per medallion step + data glossary</a:t>
             </a:r>
           </a:p>
           <a:p>
@@ -3870,7 +3813,7 @@
               </a:defRPr>
             </a:pPr>
             <a:r>
-              <a:t>Conglomerate pipeline: .../pipelines/b5d63282-...</a:t>
+              <a:t>DLT expectations enforce quality in-pipeline</a:t>
             </a:r>
           </a:p>
           <a:p>
@@ -3885,7 +3828,7 @@
               </a:defRPr>
             </a:pPr>
             <a:r>
-              <a:t>Weather pipeline: .../pipelines/c108b287-...</a:t>
+              <a:t>Three Data-Quality Monitors on gold (profiling + drift, auto dashboards)</a:t>
             </a:r>
           </a:p>
           <a:p>
@@ -3900,37 +3843,7 @@
               </a:defRPr>
             </a:pPr>
             <a:r>
-              <a:t>Weather job: .../jobs/503330163541320</a:t>
-            </a:r>
-          </a:p>
-          <a:p>
-            <a:pPr>
-              <a:spcAft>
-                <a:spcPts val="600"/>
-              </a:spcAft>
-              <a:defRPr sz="1800">
-                <a:solidFill>
-                  <a:srgbClr val="0F172A"/>
-                </a:solidFill>
-              </a:defRPr>
-            </a:pPr>
-            <a:r>
-              <a:t>Quality monitor (Resource gold): .../sql/dashboardsv3/01f1809adb1a...</a:t>
-            </a:r>
-          </a:p>
-          <a:p>
-            <a:pPr>
-              <a:spcAft>
-                <a:spcPts val="600"/>
-              </a:spcAft>
-              <a:defRPr sz="1800">
-                <a:solidFill>
-                  <a:srgbClr val="0F172A"/>
-                </a:solidFill>
-              </a:defRPr>
-            </a:pPr>
-            <a:r>
-              <a:t>Pull requests: github.com/oxiboy/poc_databricks_evalueserve/pulls</a:t>
+              <a:t>AI/BI dashboards (time series + KPIs) + SQL alert on failures</a:t>
             </a:r>
           </a:p>
         </p:txBody>

</xml_diff>

<commit_message>
docs(overview): refresh delivery docs — weather schemas, dashboards, previews & data-flow diagram
- Executive summary + technical documentation updated (weather officialized in
  dev.weather_{bronze,silver,gold}; per-source + consolidated all_sources; Chile &
  Rest of World dashboards + 2025-2026 YTD; 12-city world benchmark).
- New end-to-end data-flow diagram (dataflow.png); refreshed architecture.png.
- New previews rendered from real data/catalog: medallion-map.png,
  dashboard-chile.png, dashboard-world.png.
- Regenerated PDFs and slide deck (11 slides).
- Ignore .env on this branch.
</commit_message>
<xml_diff>
--- a/docs/overview/poc-deck.pptx
+++ b/docs/overview/poc-deck.pptx
@@ -12,6 +12,10 @@
     <p:sldId id="260" r:id="rId11"/>
     <p:sldId id="261" r:id="rId12"/>
     <p:sldId id="262" r:id="rId13"/>
+    <p:sldId id="263" r:id="rId14"/>
+    <p:sldId id="264" r:id="rId15"/>
+    <p:sldId id="265" r:id="rId16"/>
+    <p:sldId id="266" r:id="rId17"/>
   </p:sldIdLst>
   <p:sldSz cx="12191695" cy="6858000" type="screen4x3"/>
   <p:notesSz cx="6858000" cy="9144000"/>
@@ -3096,14 +3100,102 @@
       <p:grpSpPr/>
       <p:sp>
         <p:nvSpPr>
-          <p:cNvPr id="2" name="TextBox 1"/>
+          <p:cNvPr id="2" name="Rectangle 1"/>
+          <p:cNvSpPr/>
+          <p:nvPr/>
+        </p:nvSpPr>
+        <p:spPr>
+          <a:xfrm>
+            <a:off x="0" y="0"/>
+            <a:ext cx="12191695" cy="6858000"/>
+          </a:xfrm>
+          <a:prstGeom prst="rect">
+            <a:avLst/>
+          </a:prstGeom>
+          <a:solidFill>
+            <a:srgbClr val="1B2A4A"/>
+          </a:solidFill>
+          <a:ln>
+            <a:noFill/>
+          </a:ln>
+          <a:effectLst/>
+        </p:spPr>
+        <p:style>
+          <a:lnRef idx="1">
+            <a:schemeClr val="accent1"/>
+          </a:lnRef>
+          <a:fillRef idx="3">
+            <a:schemeClr val="accent1"/>
+          </a:fillRef>
+          <a:effectRef idx="2">
+            <a:schemeClr val="accent1"/>
+          </a:effectRef>
+          <a:fontRef idx="minor">
+            <a:schemeClr val="lt1"/>
+          </a:fontRef>
+        </p:style>
+        <p:txBody>
+          <a:bodyPr rtlCol="0" anchor="ctr"/>
+          <a:lstStyle/>
+          <a:p>
+            <a:pPr algn="ctr"/>
+          </a:p>
+        </p:txBody>
+      </p:sp>
+      <p:sp>
+        <p:nvSpPr>
+          <p:cNvPr id="3" name="Rectangle 2"/>
+          <p:cNvSpPr/>
+          <p:nvPr/>
+        </p:nvSpPr>
+        <p:spPr>
+          <a:xfrm>
+            <a:off x="0" y="2788920"/>
+            <a:ext cx="12191695" cy="54864"/>
+          </a:xfrm>
+          <a:prstGeom prst="rect">
+            <a:avLst/>
+          </a:prstGeom>
+          <a:solidFill>
+            <a:srgbClr val="C9A227"/>
+          </a:solidFill>
+          <a:ln>
+            <a:noFill/>
+          </a:ln>
+          <a:effectLst/>
+        </p:spPr>
+        <p:style>
+          <a:lnRef idx="1">
+            <a:schemeClr val="accent1"/>
+          </a:lnRef>
+          <a:fillRef idx="3">
+            <a:schemeClr val="accent1"/>
+          </a:fillRef>
+          <a:effectRef idx="2">
+            <a:schemeClr val="accent1"/>
+          </a:effectRef>
+          <a:fontRef idx="minor">
+            <a:schemeClr val="lt1"/>
+          </a:fontRef>
+        </p:style>
+        <p:txBody>
+          <a:bodyPr rtlCol="0" anchor="ctr"/>
+          <a:lstStyle/>
+          <a:p>
+            <a:pPr algn="ctr"/>
+          </a:p>
+        </p:txBody>
+      </p:sp>
+      <p:sp>
+        <p:nvSpPr>
+          <p:cNvPr id="4" name="TextBox 3"/>
           <p:cNvSpPr txBox="1"/>
           <p:nvPr/>
         </p:nvSpPr>
         <p:spPr>
           <a:xfrm>
-            <a:off x="914400" y="2377440"/>
-            <a:ext cx="10332720" cy="2194560"/>
+            <a:off x="731520" y="1828800"/>
+            <a:ext cx="10698480" cy="1097280"/>
           </a:xfrm>
           <a:prstGeom prst="rect">
             <a:avLst/>
@@ -3116,39 +3208,620 @@
           </a:bodyPr>
           <a:lstStyle/>
           <a:p>
-            <a:pPr algn="ctr">
-              <a:defRPr sz="4600" b="1">
-                <a:solidFill>
-                  <a:srgbClr val="0F172A"/>
-                </a:solidFill>
-              </a:defRPr>
+            <a:pPr algn="l">
+              <a:spcAft>
+                <a:spcPts val="400"/>
+              </a:spcAft>
             </a:pPr>
             <a:r>
-              <a:t>Renewable-Energy PoC</a:t>
-            </a:r>
-          </a:p>
-          <a:p>
-            <a:pPr algn="ctr">
-              <a:defRPr sz="2200">
-                <a:solidFill>
-                  <a:srgbClr val="0284C7"/>
-                </a:solidFill>
-              </a:defRPr>
+              <a:rPr sz="4000" b="1">
+                <a:solidFill>
+                  <a:srgbClr val="FFFFFF"/>
+                </a:solidFill>
+                <a:latin typeface="Calibri"/>
+              </a:rPr>
+              <a:t>Renewable-Energy Data-Engineering PoC</a:t>
+            </a:r>
+          </a:p>
+        </p:txBody>
+      </p:sp>
+      <p:sp>
+        <p:nvSpPr>
+          <p:cNvPr id="5" name="TextBox 4"/>
+          <p:cNvSpPr txBox="1"/>
+          <p:nvPr/>
+        </p:nvSpPr>
+        <p:spPr>
+          <a:xfrm>
+            <a:off x="731520" y="2971800"/>
+            <a:ext cx="10698480" cy="731520"/>
+          </a:xfrm>
+          <a:prstGeom prst="rect">
+            <a:avLst/>
+          </a:prstGeom>
+          <a:noFill/>
+        </p:spPr>
+        <p:txBody>
+          <a:bodyPr wrap="square">
+            <a:spAutoFit/>
+          </a:bodyPr>
+          <a:lstStyle/>
+          <a:p>
+            <a:pPr algn="l">
+              <a:spcAft>
+                <a:spcPts val="400"/>
+              </a:spcAft>
             </a:pPr>
             <a:r>
-              <a:t>Chilean renewable-energy medallion on Databricks</a:t>
-            </a:r>
-          </a:p>
-          <a:p>
-            <a:pPr algn="ctr">
-              <a:defRPr sz="1400" i="1">
-                <a:solidFill>
-                  <a:srgbClr val="64748B"/>
-                </a:solidFill>
-              </a:defRPr>
+              <a:rPr sz="2000" b="0">
+                <a:solidFill>
+                  <a:srgbClr val="C7D2E6"/>
+                </a:solidFill>
+                <a:latin typeface="Calibri"/>
+              </a:rPr>
+              <a:t>Chilean renewable energy · Medallion lakehouse on Databricks</a:t>
+            </a:r>
+          </a:p>
+        </p:txBody>
+      </p:sp>
+      <p:sp>
+        <p:nvSpPr>
+          <p:cNvPr id="6" name="TextBox 5"/>
+          <p:cNvSpPr txBox="1"/>
+          <p:nvPr/>
+        </p:nvSpPr>
+        <p:spPr>
+          <a:xfrm>
+            <a:off x="731520" y="3794760"/>
+            <a:ext cx="10698480" cy="1280160"/>
+          </a:xfrm>
+          <a:prstGeom prst="rect">
+            <a:avLst/>
+          </a:prstGeom>
+          <a:noFill/>
+        </p:spPr>
+        <p:txBody>
+          <a:bodyPr wrap="square">
+            <a:spAutoFit/>
+          </a:bodyPr>
+          <a:lstStyle/>
+          <a:p>
+            <a:pPr algn="l">
+              <a:spcAft>
+                <a:spcPts val="400"/>
+              </a:spcAft>
             </a:pPr>
             <a:r>
-              <a:t>4 data sources - 3 domains - governed, monitored, dashboarded - dev  |  2026-07-21</a:t>
+              <a:rPr sz="1600" b="0">
+                <a:solidFill>
+                  <a:srgbClr val="FFFFFF"/>
+                </a:solidFill>
+                <a:latin typeface="Calibri"/>
+              </a:rPr>
+              <a:t>3 domains — Weather · Resource · Conglomerate</a:t>
+            </a:r>
+          </a:p>
+          <a:p>
+            <a:pPr algn="l">
+              <a:spcAft>
+                <a:spcPts val="400"/>
+              </a:spcAft>
+            </a:pPr>
+            <a:r>
+              <a:rPr sz="1600" b="0">
+                <a:solidFill>
+                  <a:srgbClr val="FFFFFF"/>
+                </a:solidFill>
+                <a:latin typeface="Calibri"/>
+              </a:rPr>
+              <a:t>DLT · Auto Loader · Unity Catalog · AI/BI dashboards</a:t>
+            </a:r>
+          </a:p>
+          <a:p>
+            <a:pPr algn="l">
+              <a:spcAft>
+                <a:spcPts val="400"/>
+              </a:spcAft>
+            </a:pPr>
+            <a:r>
+              <a:rPr sz="1300" b="0">
+                <a:solidFill>
+                  <a:srgbClr val="9FB0CB"/>
+                </a:solidFill>
+                <a:latin typeface="Calibri"/>
+              </a:rPr>
+              <a:t>Updated 2026-07-28</a:t>
+            </a:r>
+          </a:p>
+        </p:txBody>
+      </p:sp>
+    </p:spTree>
+  </p:cSld>
+  <p:clrMapOvr>
+    <a:masterClrMapping/>
+  </p:clrMapOvr>
+</p:sld>
+</file>
+
+<file path=ppt/slides/slide10.xml><?xml version="1.0" encoding="utf-8"?>
+<p:sld xmlns:a="http://schemas.openxmlformats.org/drawingml/2006/main" xmlns:p="http://schemas.openxmlformats.org/presentationml/2006/main" xmlns:r="http://schemas.openxmlformats.org/officeDocument/2006/relationships">
+  <p:cSld>
+    <p:spTree>
+      <p:nvGrpSpPr>
+        <p:cNvPr id="1" name=""/>
+        <p:cNvGrpSpPr/>
+        <p:nvPr/>
+      </p:nvGrpSpPr>
+      <p:grpSpPr/>
+      <p:sp>
+        <p:nvSpPr>
+          <p:cNvPr id="2" name="Rectangle 1"/>
+          <p:cNvSpPr/>
+          <p:nvPr/>
+        </p:nvSpPr>
+        <p:spPr>
+          <a:xfrm>
+            <a:off x="0" y="0"/>
+            <a:ext cx="12191695" cy="1051560"/>
+          </a:xfrm>
+          <a:prstGeom prst="rect">
+            <a:avLst/>
+          </a:prstGeom>
+          <a:solidFill>
+            <a:srgbClr val="1B2A4A"/>
+          </a:solidFill>
+          <a:ln>
+            <a:noFill/>
+          </a:ln>
+          <a:effectLst/>
+        </p:spPr>
+        <p:style>
+          <a:lnRef idx="1">
+            <a:schemeClr val="accent1"/>
+          </a:lnRef>
+          <a:fillRef idx="3">
+            <a:schemeClr val="accent1"/>
+          </a:fillRef>
+          <a:effectRef idx="2">
+            <a:schemeClr val="accent1"/>
+          </a:effectRef>
+          <a:fontRef idx="minor">
+            <a:schemeClr val="lt1"/>
+          </a:fontRef>
+        </p:style>
+        <p:txBody>
+          <a:bodyPr rtlCol="0" anchor="ctr"/>
+          <a:lstStyle/>
+          <a:p>
+            <a:pPr algn="ctr"/>
+          </a:p>
+        </p:txBody>
+      </p:sp>
+      <p:sp>
+        <p:nvSpPr>
+          <p:cNvPr id="3" name="TextBox 2"/>
+          <p:cNvSpPr txBox="1"/>
+          <p:nvPr/>
+        </p:nvSpPr>
+        <p:spPr>
+          <a:xfrm>
+            <a:off x="457200" y="164592"/>
+            <a:ext cx="11247120" cy="731520"/>
+          </a:xfrm>
+          <a:prstGeom prst="rect">
+            <a:avLst/>
+          </a:prstGeom>
+          <a:noFill/>
+        </p:spPr>
+        <p:txBody>
+          <a:bodyPr wrap="square">
+            <a:spAutoFit/>
+          </a:bodyPr>
+          <a:lstStyle/>
+          <a:p>
+            <a:pPr algn="l">
+              <a:spcAft>
+                <a:spcPts val="400"/>
+              </a:spcAft>
+            </a:pPr>
+            <a:r>
+              <a:rPr sz="2600" b="1">
+                <a:solidFill>
+                  <a:srgbClr val="FFFFFF"/>
+                </a:solidFill>
+                <a:latin typeface="Calibri"/>
+              </a:rPr>
+              <a:t>Governance &amp; data quality — Databricks-native</a:t>
+            </a:r>
+          </a:p>
+        </p:txBody>
+      </p:sp>
+      <p:sp>
+        <p:nvSpPr>
+          <p:cNvPr id="4" name="TextBox 3"/>
+          <p:cNvSpPr txBox="1"/>
+          <p:nvPr/>
+        </p:nvSpPr>
+        <p:spPr>
+          <a:xfrm>
+            <a:off x="640080" y="1554480"/>
+            <a:ext cx="10972800" cy="3657600"/>
+          </a:xfrm>
+          <a:prstGeom prst="rect">
+            <a:avLst/>
+          </a:prstGeom>
+          <a:noFill/>
+        </p:spPr>
+        <p:txBody>
+          <a:bodyPr wrap="square">
+            <a:spAutoFit/>
+          </a:bodyPr>
+          <a:lstStyle/>
+          <a:p>
+            <a:pPr algn="l">
+              <a:spcAft>
+                <a:spcPts val="400"/>
+              </a:spcAft>
+            </a:pPr>
+            <a:r>
+              <a:rPr sz="1600" b="0">
+                <a:solidFill>
+                  <a:srgbClr val="22262E"/>
+                </a:solidFill>
+                <a:latin typeface="Calibri"/>
+              </a:rPr>
+              <a:t>•  Data contracts documented for every medallion step (docs/data-contracts.md).</a:t>
+            </a:r>
+          </a:p>
+          <a:p>
+            <a:pPr algn="l">
+              <a:spcAft>
+                <a:spcPts val="400"/>
+              </a:spcAft>
+            </a:pPr>
+            <a:r>
+              <a:rPr sz="1600" b="0">
+                <a:solidFill>
+                  <a:srgbClr val="22262E"/>
+                </a:solidFill>
+                <a:latin typeface="Calibri"/>
+              </a:rPr>
+              <a:t>•  DLT @dlt.expect_* on silver (Chile-bounds coords, known resource, valid keys/dates) + Delta constraints.</a:t>
+            </a:r>
+          </a:p>
+          <a:p>
+            <a:pPr algn="l">
+              <a:spcAft>
+                <a:spcPts val="400"/>
+              </a:spcAft>
+            </a:pPr>
+            <a:r>
+              <a:rPr sz="1600" b="0">
+                <a:solidFill>
+                  <a:srgbClr val="22262E"/>
+                </a:solidFill>
+                <a:latin typeface="Calibri"/>
+              </a:rPr>
+              <a:t>•  Unity Catalog automatic lineage + column &amp; table comments; business/technical glossary.</a:t>
+            </a:r>
+          </a:p>
+          <a:p>
+            <a:pPr algn="l">
+              <a:spcAft>
+                <a:spcPts val="400"/>
+              </a:spcAft>
+            </a:pPr>
+            <a:r>
+              <a:rPr sz="1600" b="0">
+                <a:solidFill>
+                  <a:srgbClr val="22262E"/>
+                </a:solidFill>
+                <a:latin typeface="Calibri"/>
+              </a:rPr>
+              <a:t>•  3 Lakehouse Data-Quality Monitors on gold (profiling + drift) + a SQL alert on failed expectations.</a:t>
+            </a:r>
+          </a:p>
+        </p:txBody>
+      </p:sp>
+    </p:spTree>
+  </p:cSld>
+  <p:clrMapOvr>
+    <a:masterClrMapping/>
+  </p:clrMapOvr>
+</p:sld>
+</file>
+
+<file path=ppt/slides/slide11.xml><?xml version="1.0" encoding="utf-8"?>
+<p:sld xmlns:a="http://schemas.openxmlformats.org/drawingml/2006/main" xmlns:p="http://schemas.openxmlformats.org/presentationml/2006/main" xmlns:r="http://schemas.openxmlformats.org/officeDocument/2006/relationships">
+  <p:cSld>
+    <p:spTree>
+      <p:nvGrpSpPr>
+        <p:cNvPr id="1" name=""/>
+        <p:cNvGrpSpPr/>
+        <p:nvPr/>
+      </p:nvGrpSpPr>
+      <p:grpSpPr/>
+      <p:sp>
+        <p:nvSpPr>
+          <p:cNvPr id="2" name="Rectangle 1"/>
+          <p:cNvSpPr/>
+          <p:nvPr/>
+        </p:nvSpPr>
+        <p:spPr>
+          <a:xfrm>
+            <a:off x="0" y="0"/>
+            <a:ext cx="12191695" cy="1051560"/>
+          </a:xfrm>
+          <a:prstGeom prst="rect">
+            <a:avLst/>
+          </a:prstGeom>
+          <a:solidFill>
+            <a:srgbClr val="1B2A4A"/>
+          </a:solidFill>
+          <a:ln>
+            <a:noFill/>
+          </a:ln>
+          <a:effectLst/>
+        </p:spPr>
+        <p:style>
+          <a:lnRef idx="1">
+            <a:schemeClr val="accent1"/>
+          </a:lnRef>
+          <a:fillRef idx="3">
+            <a:schemeClr val="accent1"/>
+          </a:fillRef>
+          <a:effectRef idx="2">
+            <a:schemeClr val="accent1"/>
+          </a:effectRef>
+          <a:fontRef idx="minor">
+            <a:schemeClr val="lt1"/>
+          </a:fontRef>
+        </p:style>
+        <p:txBody>
+          <a:bodyPr rtlCol="0" anchor="ctr"/>
+          <a:lstStyle/>
+          <a:p>
+            <a:pPr algn="ctr"/>
+          </a:p>
+        </p:txBody>
+      </p:sp>
+      <p:sp>
+        <p:nvSpPr>
+          <p:cNvPr id="3" name="TextBox 2"/>
+          <p:cNvSpPr txBox="1"/>
+          <p:nvPr/>
+        </p:nvSpPr>
+        <p:spPr>
+          <a:xfrm>
+            <a:off x="457200" y="164592"/>
+            <a:ext cx="11247120" cy="731520"/>
+          </a:xfrm>
+          <a:prstGeom prst="rect">
+            <a:avLst/>
+          </a:prstGeom>
+          <a:noFill/>
+        </p:spPr>
+        <p:txBody>
+          <a:bodyPr wrap="square">
+            <a:spAutoFit/>
+          </a:bodyPr>
+          <a:lstStyle/>
+          <a:p>
+            <a:pPr algn="l">
+              <a:spcAft>
+                <a:spcPts val="400"/>
+              </a:spcAft>
+            </a:pPr>
+            <a:r>
+              <a:rPr sz="2600" b="1">
+                <a:solidFill>
+                  <a:srgbClr val="FFFFFF"/>
+                </a:solidFill>
+                <a:latin typeface="Calibri"/>
+              </a:rPr>
+              <a:t>Status &amp; next steps</a:t>
+            </a:r>
+          </a:p>
+        </p:txBody>
+      </p:sp>
+      <p:sp>
+        <p:nvSpPr>
+          <p:cNvPr id="4" name="TextBox 3"/>
+          <p:cNvSpPr txBox="1"/>
+          <p:nvPr/>
+        </p:nvSpPr>
+        <p:spPr>
+          <a:xfrm>
+            <a:off x="640080" y="1463040"/>
+            <a:ext cx="10972800" cy="3291840"/>
+          </a:xfrm>
+          <a:prstGeom prst="rect">
+            <a:avLst/>
+          </a:prstGeom>
+          <a:noFill/>
+        </p:spPr>
+        <p:txBody>
+          <a:bodyPr wrap="square">
+            <a:spAutoFit/>
+          </a:bodyPr>
+          <a:lstStyle/>
+          <a:p>
+            <a:pPr algn="l">
+              <a:spcAft>
+                <a:spcPts val="400"/>
+              </a:spcAft>
+            </a:pPr>
+            <a:r>
+              <a:rPr sz="1600" b="1">
+                <a:solidFill>
+                  <a:srgbClr val="2E8B72"/>
+                </a:solidFill>
+                <a:latin typeface="Calibri"/>
+              </a:rPr>
+              <a:t>Delivered &amp; verified in dev — consolidated in delivery ticket Trello #74.</a:t>
+            </a:r>
+          </a:p>
+          <a:p>
+            <a:pPr algn="l">
+              <a:spcAft>
+                <a:spcPts val="400"/>
+              </a:spcAft>
+            </a:pPr>
+            <a:r>
+              <a:rPr sz="1400" b="0">
+                <a:solidFill>
+                  <a:srgbClr val="22262E"/>
+                </a:solidFill>
+                <a:latin typeface="Calibri"/>
+              </a:rPr>
+              <a:t>Weather complete across the medallion (raw / silver / gold) in dedicated schemas + dashboards.</a:t>
+            </a:r>
+          </a:p>
+          <a:p>
+            <a:pPr algn="l">
+              <a:spcAft>
+                <a:spcPts val="400"/>
+              </a:spcAft>
+            </a:pPr>
+            <a:r>
+              <a:rPr sz="800" b="0">
+                <a:solidFill>
+                  <a:srgbClr val="22262E"/>
+                </a:solidFill>
+                <a:latin typeface="Calibri"/>
+              </a:rPr>
+              <a:t/>
+            </a:r>
+          </a:p>
+          <a:p>
+            <a:pPr algn="l">
+              <a:spcAft>
+                <a:spcPts val="400"/>
+              </a:spcAft>
+            </a:pPr>
+            <a:r>
+              <a:rPr sz="1400" b="0">
+                <a:solidFill>
+                  <a:srgbClr val="22262E"/>
+                </a:solidFill>
+                <a:latin typeface="Calibri"/>
+              </a:rPr>
+              <a:t>PRs #24–#28 were closed without merge (team's main advanced separately); work lives on fork branches, ready to re-integrate.</a:t>
+            </a:r>
+          </a:p>
+          <a:p>
+            <a:pPr algn="l">
+              <a:spcAft>
+                <a:spcPts val="400"/>
+              </a:spcAft>
+            </a:pPr>
+            <a:r>
+              <a:rPr sz="1400" b="0">
+                <a:solidFill>
+                  <a:srgbClr val="22262E"/>
+                </a:solidFill>
+                <a:latin typeface="Calibri"/>
+              </a:rPr>
+              <a:t>Priority: CI fix (#27) — old CI deploys to prod on approval and runs no tests.</a:t>
+            </a:r>
+          </a:p>
+          <a:p>
+            <a:pPr algn="l">
+              <a:spcAft>
+                <a:spcPts val="400"/>
+              </a:spcAft>
+            </a:pPr>
+            <a:r>
+              <a:rPr sz="1400" b="0">
+                <a:solidFill>
+                  <a:srgbClr val="22262E"/>
+                </a:solidFill>
+                <a:latin typeface="Calibri"/>
+              </a:rPr>
+              <a:t>Next: wire DMC real-time as a job; make fetchers incremental; re-integrate branches with the project lead.</a:t>
+            </a:r>
+          </a:p>
+        </p:txBody>
+      </p:sp>
+      <p:sp>
+        <p:nvSpPr>
+          <p:cNvPr id="5" name="Rectangle 4"/>
+          <p:cNvSpPr/>
+          <p:nvPr/>
+        </p:nvSpPr>
+        <p:spPr>
+          <a:xfrm>
+            <a:off x="640080" y="5669280"/>
+            <a:ext cx="10972800" cy="45720"/>
+          </a:xfrm>
+          <a:prstGeom prst="rect">
+            <a:avLst/>
+          </a:prstGeom>
+          <a:solidFill>
+            <a:srgbClr val="C9A227"/>
+          </a:solidFill>
+          <a:ln>
+            <a:noFill/>
+          </a:ln>
+          <a:effectLst/>
+        </p:spPr>
+        <p:style>
+          <a:lnRef idx="1">
+            <a:schemeClr val="accent1"/>
+          </a:lnRef>
+          <a:fillRef idx="3">
+            <a:schemeClr val="accent1"/>
+          </a:fillRef>
+          <a:effectRef idx="2">
+            <a:schemeClr val="accent1"/>
+          </a:effectRef>
+          <a:fontRef idx="minor">
+            <a:schemeClr val="lt1"/>
+          </a:fontRef>
+        </p:style>
+        <p:txBody>
+          <a:bodyPr rtlCol="0" anchor="ctr"/>
+          <a:lstStyle/>
+          <a:p>
+            <a:pPr algn="ctr"/>
+          </a:p>
+        </p:txBody>
+      </p:sp>
+      <p:sp>
+        <p:nvSpPr>
+          <p:cNvPr id="6" name="TextBox 5"/>
+          <p:cNvSpPr txBox="1"/>
+          <p:nvPr/>
+        </p:nvSpPr>
+        <p:spPr>
+          <a:xfrm>
+            <a:off x="640080" y="5806440"/>
+            <a:ext cx="10972800" cy="457200"/>
+          </a:xfrm>
+          <a:prstGeom prst="rect">
+            <a:avLst/>
+          </a:prstGeom>
+          <a:noFill/>
+        </p:spPr>
+        <p:txBody>
+          <a:bodyPr wrap="square">
+            <a:spAutoFit/>
+          </a:bodyPr>
+          <a:lstStyle/>
+          <a:p>
+            <a:pPr algn="l">
+              <a:spcAft>
+                <a:spcPts val="400"/>
+              </a:spcAft>
+            </a:pPr>
+            <a:r>
+              <a:rPr sz="1200" b="0">
+                <a:solidFill>
+                  <a:srgbClr val="555B66"/>
+                </a:solidFill>
+                <a:latin typeface="Calibri"/>
+              </a:rPr>
+              <a:t>All work in dev + branches; production is the project lead's.</a:t>
             </a:r>
           </a:p>
         </p:txBody>
@@ -3173,14 +3846,58 @@
       <p:grpSpPr/>
       <p:sp>
         <p:nvSpPr>
-          <p:cNvPr id="2" name="TextBox 1"/>
+          <p:cNvPr id="2" name="Rectangle 1"/>
+          <p:cNvSpPr/>
+          <p:nvPr/>
+        </p:nvSpPr>
+        <p:spPr>
+          <a:xfrm>
+            <a:off x="0" y="0"/>
+            <a:ext cx="12191695" cy="1051560"/>
+          </a:xfrm>
+          <a:prstGeom prst="rect">
+            <a:avLst/>
+          </a:prstGeom>
+          <a:solidFill>
+            <a:srgbClr val="1B2A4A"/>
+          </a:solidFill>
+          <a:ln>
+            <a:noFill/>
+          </a:ln>
+          <a:effectLst/>
+        </p:spPr>
+        <p:style>
+          <a:lnRef idx="1">
+            <a:schemeClr val="accent1"/>
+          </a:lnRef>
+          <a:fillRef idx="3">
+            <a:schemeClr val="accent1"/>
+          </a:fillRef>
+          <a:effectRef idx="2">
+            <a:schemeClr val="accent1"/>
+          </a:effectRef>
+          <a:fontRef idx="minor">
+            <a:schemeClr val="lt1"/>
+          </a:fontRef>
+        </p:style>
+        <p:txBody>
+          <a:bodyPr rtlCol="0" anchor="ctr"/>
+          <a:lstStyle/>
+          <a:p>
+            <a:pPr algn="ctr"/>
+          </a:p>
+        </p:txBody>
+      </p:sp>
+      <p:sp>
+        <p:nvSpPr>
+          <p:cNvPr id="3" name="TextBox 2"/>
           <p:cNvSpPr txBox="1"/>
           <p:nvPr/>
         </p:nvSpPr>
         <p:spPr>
           <a:xfrm>
-            <a:off x="548640" y="365760"/>
-            <a:ext cx="11064240" cy="914400"/>
+            <a:off x="457200" y="164592"/>
+            <a:ext cx="11247120" cy="731520"/>
           </a:xfrm>
           <a:prstGeom prst="rect">
             <a:avLst/>
@@ -3193,41 +3910,33 @@
           </a:bodyPr>
           <a:lstStyle/>
           <a:p>
-            <a:pPr>
-              <a:defRPr sz="3000" b="1">
-                <a:solidFill>
-                  <a:srgbClr val="0284C7"/>
-                </a:solidFill>
-              </a:defRPr>
+            <a:pPr algn="l">
+              <a:spcAft>
+                <a:spcPts val="400"/>
+              </a:spcAft>
             </a:pPr>
             <a:r>
-              <a:t>Four data sources - all real data</a:t>
-            </a:r>
-          </a:p>
-          <a:p>
-            <a:pPr>
-              <a:defRPr sz="1300" i="1">
-                <a:solidFill>
-                  <a:srgbClr val="64748B"/>
-                </a:solidFill>
-              </a:defRPr>
-            </a:pPr>
-            <a:r>
-              <a:t>The ingestion layer</a:t>
-            </a:r>
-          </a:p>
-        </p:txBody>
-      </p:sp>
-      <p:sp>
-        <p:nvSpPr>
-          <p:cNvPr id="3" name="TextBox 2"/>
+              <a:rPr sz="2600" b="1">
+                <a:solidFill>
+                  <a:srgbClr val="FFFFFF"/>
+                </a:solidFill>
+                <a:latin typeface="Calibri"/>
+              </a:rPr>
+              <a:t>Architecture</a:t>
+            </a:r>
+          </a:p>
+        </p:txBody>
+      </p:sp>
+      <p:sp>
+        <p:nvSpPr>
+          <p:cNvPr id="4" name="TextBox 3"/>
           <p:cNvSpPr txBox="1"/>
           <p:nvPr/>
         </p:nvSpPr>
         <p:spPr>
           <a:xfrm>
-            <a:off x="640080" y="1554480"/>
-            <a:ext cx="10881360" cy="4937760"/>
+            <a:off x="457200" y="658368"/>
+            <a:ext cx="11247120" cy="365760"/>
           </a:xfrm>
           <a:prstGeom prst="rect">
             <a:avLst/>
@@ -3240,52 +3949,47 @@
           </a:bodyPr>
           <a:lstStyle/>
           <a:p>
-            <a:pPr>
+            <a:pPr algn="l">
               <a:spcAft>
-                <a:spcPts val="600"/>
+                <a:spcPts val="400"/>
               </a:spcAft>
-              <a:defRPr sz="1800">
-                <a:solidFill>
-                  <a:srgbClr val="0F172A"/>
-                </a:solidFill>
-              </a:defRPr>
             </a:pPr>
             <a:r>
-              <a:t>Weather: NASA POWER (historical) + DMC (real-time) + MinEnergia/DGF (modeled)</a:t>
-            </a:r>
-          </a:p>
-          <a:p>
-            <a:pPr>
-              <a:spcAft>
-                <a:spcPts val="600"/>
-              </a:spcAft>
-              <a:defRPr sz="1800">
-                <a:solidFill>
-                  <a:srgbClr val="0F172A"/>
-                </a:solidFill>
-              </a:defRPr>
-            </a:pPr>
-            <a:r>
-              <a:t>Resource (generation): CEN - public by law, no cost</a:t>
-            </a:r>
-          </a:p>
-          <a:p>
-            <a:pPr>
-              <a:spcAft>
-                <a:spcPts val="600"/>
-              </a:spcAft>
-              <a:defRPr sz="1800">
-                <a:solidFill>
-                  <a:srgbClr val="0F172A"/>
-                </a:solidFill>
-              </a:defRPr>
-            </a:pPr>
-            <a:r>
-              <a:t>Conglomerate (country): OWID - open CSV</a:t>
-            </a:r>
-          </a:p>
-        </p:txBody>
-      </p:sp>
+              <a:rPr sz="1200" b="0">
+                <a:solidFill>
+                  <a:srgbClr val="C7D2E6"/>
+                </a:solidFill>
+                <a:latin typeface="Calibri"/>
+              </a:rPr>
+              <a:t>Sources → Ingestion → Bronze → Silver → Gold → Consumption · governed by Unity Catalog</a:t>
+            </a:r>
+          </a:p>
+        </p:txBody>
+      </p:sp>
+      <p:pic>
+        <p:nvPicPr>
+          <p:cNvPr id="5" name="Picture 4" descr="architecture.png"/>
+          <p:cNvPicPr>
+            <a:picLocks noChangeAspect="1"/>
+          </p:cNvPicPr>
+          <p:nvPr/>
+        </p:nvPicPr>
+        <p:blipFill>
+          <a:blip r:embed="rId2"/>
+          <a:stretch>
+            <a:fillRect/>
+          </a:stretch>
+        </p:blipFill>
+        <p:spPr>
+          <a:xfrm>
+            <a:off x="457200" y="1371600"/>
+            <a:ext cx="11274552" cy="6431791"/>
+          </a:xfrm>
+          <a:prstGeom prst="rect">
+            <a:avLst/>
+          </a:prstGeom>
+        </p:spPr>
+      </p:pic>
     </p:spTree>
   </p:cSld>
   <p:clrMapOvr>
@@ -3306,14 +4010,58 @@
       <p:grpSpPr/>
       <p:sp>
         <p:nvSpPr>
-          <p:cNvPr id="2" name="TextBox 1"/>
+          <p:cNvPr id="2" name="Rectangle 1"/>
+          <p:cNvSpPr/>
+          <p:nvPr/>
+        </p:nvSpPr>
+        <p:spPr>
+          <a:xfrm>
+            <a:off x="0" y="0"/>
+            <a:ext cx="12191695" cy="1051560"/>
+          </a:xfrm>
+          <a:prstGeom prst="rect">
+            <a:avLst/>
+          </a:prstGeom>
+          <a:solidFill>
+            <a:srgbClr val="1B2A4A"/>
+          </a:solidFill>
+          <a:ln>
+            <a:noFill/>
+          </a:ln>
+          <a:effectLst/>
+        </p:spPr>
+        <p:style>
+          <a:lnRef idx="1">
+            <a:schemeClr val="accent1"/>
+          </a:lnRef>
+          <a:fillRef idx="3">
+            <a:schemeClr val="accent1"/>
+          </a:fillRef>
+          <a:effectRef idx="2">
+            <a:schemeClr val="accent1"/>
+          </a:effectRef>
+          <a:fontRef idx="minor">
+            <a:schemeClr val="lt1"/>
+          </a:fontRef>
+        </p:style>
+        <p:txBody>
+          <a:bodyPr rtlCol="0" anchor="ctr"/>
+          <a:lstStyle/>
+          <a:p>
+            <a:pPr algn="ctr"/>
+          </a:p>
+        </p:txBody>
+      </p:sp>
+      <p:sp>
+        <p:nvSpPr>
+          <p:cNvPr id="3" name="TextBox 2"/>
           <p:cNvSpPr txBox="1"/>
           <p:nvPr/>
         </p:nvSpPr>
         <p:spPr>
           <a:xfrm>
-            <a:off x="548640" y="274320"/>
-            <a:ext cx="11064240" cy="731520"/>
+            <a:off x="457200" y="164592"/>
+            <a:ext cx="11247120" cy="731520"/>
           </a:xfrm>
           <a:prstGeom prst="rect">
             <a:avLst/>
@@ -3321,48 +4069,433 @@
           <a:noFill/>
         </p:spPr>
         <p:txBody>
-          <a:bodyPr wrap="none">
+          <a:bodyPr wrap="square">
             <a:spAutoFit/>
           </a:bodyPr>
           <a:lstStyle/>
           <a:p>
-            <a:pPr>
-              <a:defRPr sz="2600" b="1">
-                <a:solidFill>
-                  <a:srgbClr val="0284C7"/>
-                </a:solidFill>
-              </a:defRPr>
+            <a:pPr algn="l">
+              <a:spcAft>
+                <a:spcPts val="400"/>
+              </a:spcAft>
             </a:pPr>
             <a:r>
-              <a:t>Architecture (medallion on Databricks)</a:t>
-            </a:r>
-          </a:p>
-        </p:txBody>
-      </p:sp>
-      <p:pic>
-        <p:nvPicPr>
-          <p:cNvPr id="3" name="Picture 2" descr="architecture.png"/>
-          <p:cNvPicPr>
-            <a:picLocks noChangeAspect="1"/>
-          </p:cNvPicPr>
-          <p:nvPr/>
-        </p:nvPicPr>
-        <p:blipFill>
-          <a:blip r:embed="rId2"/>
-          <a:stretch>
-            <a:fillRect/>
-          </a:stretch>
-        </p:blipFill>
-        <p:spPr>
-          <a:xfrm>
-            <a:off x="457200" y="1143000"/>
-            <a:ext cx="11247120" cy="6351825"/>
-          </a:xfrm>
-          <a:prstGeom prst="rect">
-            <a:avLst/>
-          </a:prstGeom>
-        </p:spPr>
-      </p:pic>
+              <a:rPr sz="2600" b="1">
+                <a:solidFill>
+                  <a:srgbClr val="FFFFFF"/>
+                </a:solidFill>
+                <a:latin typeface="Calibri"/>
+              </a:rPr>
+              <a:t>Data sources — all on real data</a:t>
+            </a:r>
+          </a:p>
+        </p:txBody>
+      </p:sp>
+      <p:sp>
+        <p:nvSpPr>
+          <p:cNvPr id="4" name="Rectangle 3"/>
+          <p:cNvSpPr/>
+          <p:nvPr/>
+        </p:nvSpPr>
+        <p:spPr>
+          <a:xfrm>
+            <a:off x="457200" y="1508760"/>
+            <a:ext cx="164592" cy="1234440"/>
+          </a:xfrm>
+          <a:prstGeom prst="rect">
+            <a:avLst/>
+          </a:prstGeom>
+          <a:solidFill>
+            <a:srgbClr val="C9A227"/>
+          </a:solidFill>
+          <a:ln>
+            <a:noFill/>
+          </a:ln>
+          <a:effectLst/>
+        </p:spPr>
+        <p:style>
+          <a:lnRef idx="1">
+            <a:schemeClr val="accent1"/>
+          </a:lnRef>
+          <a:fillRef idx="3">
+            <a:schemeClr val="accent1"/>
+          </a:fillRef>
+          <a:effectRef idx="2">
+            <a:schemeClr val="accent1"/>
+          </a:effectRef>
+          <a:fontRef idx="minor">
+            <a:schemeClr val="lt1"/>
+          </a:fontRef>
+        </p:style>
+        <p:txBody>
+          <a:bodyPr rtlCol="0" anchor="ctr"/>
+          <a:lstStyle/>
+          <a:p>
+            <a:pPr algn="ctr"/>
+          </a:p>
+        </p:txBody>
+      </p:sp>
+      <p:sp>
+        <p:nvSpPr>
+          <p:cNvPr id="5" name="TextBox 4"/>
+          <p:cNvSpPr txBox="1"/>
+          <p:nvPr/>
+        </p:nvSpPr>
+        <p:spPr>
+          <a:xfrm>
+            <a:off x="777240" y="1554480"/>
+            <a:ext cx="3108960" cy="1097280"/>
+          </a:xfrm>
+          <a:prstGeom prst="rect">
+            <a:avLst/>
+          </a:prstGeom>
+          <a:noFill/>
+        </p:spPr>
+        <p:txBody>
+          <a:bodyPr wrap="square">
+            <a:spAutoFit/>
+          </a:bodyPr>
+          <a:lstStyle/>
+          <a:p>
+            <a:pPr algn="l">
+              <a:spcAft>
+                <a:spcPts val="400"/>
+              </a:spcAft>
+            </a:pPr>
+            <a:r>
+              <a:rPr sz="1800" b="1">
+                <a:solidFill>
+                  <a:srgbClr val="1B2A4A"/>
+                </a:solidFill>
+                <a:latin typeface="Calibri"/>
+              </a:rPr>
+              <a:t>Weather</a:t>
+            </a:r>
+          </a:p>
+        </p:txBody>
+      </p:sp>
+      <p:sp>
+        <p:nvSpPr>
+          <p:cNvPr id="6" name="TextBox 5"/>
+          <p:cNvSpPr txBox="1"/>
+          <p:nvPr/>
+        </p:nvSpPr>
+        <p:spPr>
+          <a:xfrm>
+            <a:off x="3931920" y="1554480"/>
+            <a:ext cx="7772400" cy="1097280"/>
+          </a:xfrm>
+          <a:prstGeom prst="rect">
+            <a:avLst/>
+          </a:prstGeom>
+          <a:noFill/>
+        </p:spPr>
+        <p:txBody>
+          <a:bodyPr wrap="square">
+            <a:spAutoFit/>
+          </a:bodyPr>
+          <a:lstStyle/>
+          <a:p>
+            <a:pPr algn="l">
+              <a:spcAft>
+                <a:spcPts val="400"/>
+              </a:spcAft>
+            </a:pPr>
+            <a:r>
+              <a:rPr sz="1400" b="0">
+                <a:solidFill>
+                  <a:srgbClr val="22262E"/>
+                </a:solidFill>
+                <a:latin typeface="Calibri"/>
+              </a:rPr>
+              <a:t>NASA POWER (hist hourly + 12-city world daily) · DMC (real-time) · MinEnergía/DGF (modeled)</a:t>
+            </a:r>
+          </a:p>
+        </p:txBody>
+      </p:sp>
+      <p:sp>
+        <p:nvSpPr>
+          <p:cNvPr id="7" name="Rectangle 6"/>
+          <p:cNvSpPr/>
+          <p:nvPr/>
+        </p:nvSpPr>
+        <p:spPr>
+          <a:xfrm>
+            <a:off x="457200" y="2926080"/>
+            <a:ext cx="164592" cy="1234440"/>
+          </a:xfrm>
+          <a:prstGeom prst="rect">
+            <a:avLst/>
+          </a:prstGeom>
+          <a:solidFill>
+            <a:srgbClr val="B84A4A"/>
+          </a:solidFill>
+          <a:ln>
+            <a:noFill/>
+          </a:ln>
+          <a:effectLst/>
+        </p:spPr>
+        <p:style>
+          <a:lnRef idx="1">
+            <a:schemeClr val="accent1"/>
+          </a:lnRef>
+          <a:fillRef idx="3">
+            <a:schemeClr val="accent1"/>
+          </a:fillRef>
+          <a:effectRef idx="2">
+            <a:schemeClr val="accent1"/>
+          </a:effectRef>
+          <a:fontRef idx="minor">
+            <a:schemeClr val="lt1"/>
+          </a:fontRef>
+        </p:style>
+        <p:txBody>
+          <a:bodyPr rtlCol="0" anchor="ctr"/>
+          <a:lstStyle/>
+          <a:p>
+            <a:pPr algn="ctr"/>
+          </a:p>
+        </p:txBody>
+      </p:sp>
+      <p:sp>
+        <p:nvSpPr>
+          <p:cNvPr id="8" name="TextBox 7"/>
+          <p:cNvSpPr txBox="1"/>
+          <p:nvPr/>
+        </p:nvSpPr>
+        <p:spPr>
+          <a:xfrm>
+            <a:off x="777240" y="2971800"/>
+            <a:ext cx="3108960" cy="1097280"/>
+          </a:xfrm>
+          <a:prstGeom prst="rect">
+            <a:avLst/>
+          </a:prstGeom>
+          <a:noFill/>
+        </p:spPr>
+        <p:txBody>
+          <a:bodyPr wrap="square">
+            <a:spAutoFit/>
+          </a:bodyPr>
+          <a:lstStyle/>
+          <a:p>
+            <a:pPr algn="l">
+              <a:spcAft>
+                <a:spcPts val="400"/>
+              </a:spcAft>
+            </a:pPr>
+            <a:r>
+              <a:rPr sz="1800" b="1">
+                <a:solidFill>
+                  <a:srgbClr val="1B2A4A"/>
+                </a:solidFill>
+                <a:latin typeface="Calibri"/>
+              </a:rPr>
+              <a:t>Resource — generation</a:t>
+            </a:r>
+          </a:p>
+        </p:txBody>
+      </p:sp>
+      <p:sp>
+        <p:nvSpPr>
+          <p:cNvPr id="9" name="TextBox 8"/>
+          <p:cNvSpPr txBox="1"/>
+          <p:nvPr/>
+        </p:nvSpPr>
+        <p:spPr>
+          <a:xfrm>
+            <a:off x="3931920" y="2971800"/>
+            <a:ext cx="7772400" cy="1097280"/>
+          </a:xfrm>
+          <a:prstGeom prst="rect">
+            <a:avLst/>
+          </a:prstGeom>
+          <a:noFill/>
+        </p:spPr>
+        <p:txBody>
+          <a:bodyPr wrap="square">
+            <a:spAutoFit/>
+          </a:bodyPr>
+          <a:lstStyle/>
+          <a:p>
+            <a:pPr algn="l">
+              <a:spcAft>
+                <a:spcPts val="400"/>
+              </a:spcAft>
+            </a:pPr>
+            <a:r>
+              <a:rPr sz="1400" b="0">
+                <a:solidFill>
+                  <a:srgbClr val="22262E"/>
+                </a:solidFill>
+                <a:latin typeface="Calibri"/>
+              </a:rPr>
+              <a:t>CEN / Coordinador — public by law (Art. 72-8, Ley 20.936), public key, no cost</a:t>
+            </a:r>
+          </a:p>
+        </p:txBody>
+      </p:sp>
+      <p:sp>
+        <p:nvSpPr>
+          <p:cNvPr id="10" name="Rectangle 9"/>
+          <p:cNvSpPr/>
+          <p:nvPr/>
+        </p:nvSpPr>
+        <p:spPr>
+          <a:xfrm>
+            <a:off x="457200" y="4343400"/>
+            <a:ext cx="164592" cy="1234440"/>
+          </a:xfrm>
+          <a:prstGeom prst="rect">
+            <a:avLst/>
+          </a:prstGeom>
+          <a:solidFill>
+            <a:srgbClr val="2E8B72"/>
+          </a:solidFill>
+          <a:ln>
+            <a:noFill/>
+          </a:ln>
+          <a:effectLst/>
+        </p:spPr>
+        <p:style>
+          <a:lnRef idx="1">
+            <a:schemeClr val="accent1"/>
+          </a:lnRef>
+          <a:fillRef idx="3">
+            <a:schemeClr val="accent1"/>
+          </a:fillRef>
+          <a:effectRef idx="2">
+            <a:schemeClr val="accent1"/>
+          </a:effectRef>
+          <a:fontRef idx="minor">
+            <a:schemeClr val="lt1"/>
+          </a:fontRef>
+        </p:style>
+        <p:txBody>
+          <a:bodyPr rtlCol="0" anchor="ctr"/>
+          <a:lstStyle/>
+          <a:p>
+            <a:pPr algn="ctr"/>
+          </a:p>
+        </p:txBody>
+      </p:sp>
+      <p:sp>
+        <p:nvSpPr>
+          <p:cNvPr id="11" name="TextBox 10"/>
+          <p:cNvSpPr txBox="1"/>
+          <p:nvPr/>
+        </p:nvSpPr>
+        <p:spPr>
+          <a:xfrm>
+            <a:off x="777240" y="4389120"/>
+            <a:ext cx="3108960" cy="1097280"/>
+          </a:xfrm>
+          <a:prstGeom prst="rect">
+            <a:avLst/>
+          </a:prstGeom>
+          <a:noFill/>
+        </p:spPr>
+        <p:txBody>
+          <a:bodyPr wrap="square">
+            <a:spAutoFit/>
+          </a:bodyPr>
+          <a:lstStyle/>
+          <a:p>
+            <a:pPr algn="l">
+              <a:spcAft>
+                <a:spcPts val="400"/>
+              </a:spcAft>
+            </a:pPr>
+            <a:r>
+              <a:rPr sz="1800" b="1">
+                <a:solidFill>
+                  <a:srgbClr val="1B2A4A"/>
+                </a:solidFill>
+                <a:latin typeface="Calibri"/>
+              </a:rPr>
+              <a:t>Conglomerate — country</a:t>
+            </a:r>
+          </a:p>
+        </p:txBody>
+      </p:sp>
+      <p:sp>
+        <p:nvSpPr>
+          <p:cNvPr id="12" name="TextBox 11"/>
+          <p:cNvSpPr txBox="1"/>
+          <p:nvPr/>
+        </p:nvSpPr>
+        <p:spPr>
+          <a:xfrm>
+            <a:off x="3931920" y="4389120"/>
+            <a:ext cx="7772400" cy="1097280"/>
+          </a:xfrm>
+          <a:prstGeom prst="rect">
+            <a:avLst/>
+          </a:prstGeom>
+          <a:noFill/>
+        </p:spPr>
+        <p:txBody>
+          <a:bodyPr wrap="square">
+            <a:spAutoFit/>
+          </a:bodyPr>
+          <a:lstStyle/>
+          <a:p>
+            <a:pPr algn="l">
+              <a:spcAft>
+                <a:spcPts val="400"/>
+              </a:spcAft>
+            </a:pPr>
+            <a:r>
+              <a:rPr sz="1400" b="0">
+                <a:solidFill>
+                  <a:srgbClr val="22262E"/>
+                </a:solidFill>
+                <a:latin typeface="Calibri"/>
+              </a:rPr>
+              <a:t>Our World in Data (OWID) — open CSV, Chile vs LATAM / World</a:t>
+            </a:r>
+          </a:p>
+        </p:txBody>
+      </p:sp>
+      <p:sp>
+        <p:nvSpPr>
+          <p:cNvPr id="13" name="TextBox 12"/>
+          <p:cNvSpPr txBox="1"/>
+          <p:nvPr/>
+        </p:nvSpPr>
+        <p:spPr>
+          <a:xfrm>
+            <a:off x="777240" y="5806440"/>
+            <a:ext cx="10972800" cy="548640"/>
+          </a:xfrm>
+          <a:prstGeom prst="rect">
+            <a:avLst/>
+          </a:prstGeom>
+          <a:noFill/>
+        </p:spPr>
+        <p:txBody>
+          <a:bodyPr wrap="square">
+            <a:spAutoFit/>
+          </a:bodyPr>
+          <a:lstStyle/>
+          <a:p>
+            <a:pPr algn="l">
+              <a:spcAft>
+                <a:spcPts val="400"/>
+              </a:spcAft>
+            </a:pPr>
+            <a:r>
+              <a:rPr sz="1300" b="0">
+                <a:solidFill>
+                  <a:srgbClr val="555B66"/>
+                </a:solidFill>
+                <a:latin typeface="Calibri"/>
+              </a:rPr>
+              <a:t>Key unblock: CEN generation is public by law (no paid SIPUB account needed); NASA POWER serves clean history + a world benchmark.</a:t>
+            </a:r>
+          </a:p>
+        </p:txBody>
+      </p:sp>
     </p:spTree>
   </p:cSld>
   <p:clrMapOvr>
@@ -3383,14 +4516,58 @@
       <p:grpSpPr/>
       <p:sp>
         <p:nvSpPr>
-          <p:cNvPr id="2" name="TextBox 1"/>
+          <p:cNvPr id="2" name="Rectangle 1"/>
+          <p:cNvSpPr/>
+          <p:nvPr/>
+        </p:nvSpPr>
+        <p:spPr>
+          <a:xfrm>
+            <a:off x="0" y="0"/>
+            <a:ext cx="12191695" cy="1051560"/>
+          </a:xfrm>
+          <a:prstGeom prst="rect">
+            <a:avLst/>
+          </a:prstGeom>
+          <a:solidFill>
+            <a:srgbClr val="1B2A4A"/>
+          </a:solidFill>
+          <a:ln>
+            <a:noFill/>
+          </a:ln>
+          <a:effectLst/>
+        </p:spPr>
+        <p:style>
+          <a:lnRef idx="1">
+            <a:schemeClr val="accent1"/>
+          </a:lnRef>
+          <a:fillRef idx="3">
+            <a:schemeClr val="accent1"/>
+          </a:fillRef>
+          <a:effectRef idx="2">
+            <a:schemeClr val="accent1"/>
+          </a:effectRef>
+          <a:fontRef idx="minor">
+            <a:schemeClr val="lt1"/>
+          </a:fontRef>
+        </p:style>
+        <p:txBody>
+          <a:bodyPr rtlCol="0" anchor="ctr"/>
+          <a:lstStyle/>
+          <a:p>
+            <a:pPr algn="ctr"/>
+          </a:p>
+        </p:txBody>
+      </p:sp>
+      <p:sp>
+        <p:nvSpPr>
+          <p:cNvPr id="3" name="TextBox 2"/>
           <p:cNvSpPr txBox="1"/>
           <p:nvPr/>
         </p:nvSpPr>
         <p:spPr>
           <a:xfrm>
-            <a:off x="548640" y="274320"/>
-            <a:ext cx="11064240" cy="731520"/>
+            <a:off x="457200" y="164592"/>
+            <a:ext cx="11247120" cy="731520"/>
           </a:xfrm>
           <a:prstGeom prst="rect">
             <a:avLst/>
@@ -3398,48 +4575,584 @@
           <a:noFill/>
         </p:spPr>
         <p:txBody>
-          <a:bodyPr wrap="none">
+          <a:bodyPr wrap="square">
             <a:spAutoFit/>
           </a:bodyPr>
           <a:lstStyle/>
           <a:p>
-            <a:pPr>
-              <a:defRPr sz="2600" b="1">
-                <a:solidFill>
-                  <a:srgbClr val="0284C7"/>
-                </a:solidFill>
-              </a:defRPr>
+            <a:pPr algn="l">
+              <a:spcAft>
+                <a:spcPts val="400"/>
+              </a:spcAft>
             </a:pPr>
             <a:r>
-              <a:t>End-to-end workflow</a:t>
-            </a:r>
-          </a:p>
-        </p:txBody>
-      </p:sp>
-      <p:pic>
-        <p:nvPicPr>
-          <p:cNvPr id="3" name="Picture 2" descr="workflow.png"/>
-          <p:cNvPicPr>
-            <a:picLocks noChangeAspect="1"/>
-          </p:cNvPicPr>
-          <p:nvPr/>
-        </p:nvPicPr>
-        <p:blipFill>
-          <a:blip r:embed="rId2"/>
-          <a:stretch>
-            <a:fillRect/>
-          </a:stretch>
-        </p:blipFill>
-        <p:spPr>
-          <a:xfrm>
-            <a:off x="457200" y="1143000"/>
-            <a:ext cx="11247120" cy="6211960"/>
-          </a:xfrm>
-          <a:prstGeom prst="rect">
-            <a:avLst/>
-          </a:prstGeom>
-        </p:spPr>
-      </p:pic>
+              <a:rPr sz="2600" b="1">
+                <a:solidFill>
+                  <a:srgbClr val="FFFFFF"/>
+                </a:solidFill>
+                <a:latin typeface="Calibri"/>
+              </a:rPr>
+              <a:t>Weather officialized in dedicated schemas</a:t>
+            </a:r>
+          </a:p>
+        </p:txBody>
+      </p:sp>
+      <p:sp>
+        <p:nvSpPr>
+          <p:cNvPr id="4" name="TextBox 3"/>
+          <p:cNvSpPr txBox="1"/>
+          <p:nvPr/>
+        </p:nvSpPr>
+        <p:spPr>
+          <a:xfrm>
+            <a:off x="457200" y="658368"/>
+            <a:ext cx="11247120" cy="365760"/>
+          </a:xfrm>
+          <a:prstGeom prst="rect">
+            <a:avLst/>
+          </a:prstGeom>
+          <a:noFill/>
+        </p:spPr>
+        <p:txBody>
+          <a:bodyPr wrap="square">
+            <a:spAutoFit/>
+          </a:bodyPr>
+          <a:lstStyle/>
+          <a:p>
+            <a:pPr algn="l">
+              <a:spcAft>
+                <a:spcPts val="400"/>
+              </a:spcAft>
+            </a:pPr>
+            <a:r>
+              <a:rPr sz="1200" b="0">
+                <a:solidFill>
+                  <a:srgbClr val="C7D2E6"/>
+                </a:solidFill>
+                <a:latin typeface="Calibri"/>
+              </a:rPr>
+              <a:t>dev.weather_bronze / _silver / _gold — per-source + one consolidated all_sources per layer</a:t>
+            </a:r>
+          </a:p>
+        </p:txBody>
+      </p:sp>
+      <p:sp>
+        <p:nvSpPr>
+          <p:cNvPr id="5" name="Rectangle 4"/>
+          <p:cNvSpPr/>
+          <p:nvPr/>
+        </p:nvSpPr>
+        <p:spPr>
+          <a:xfrm>
+            <a:off x="548640" y="1554480"/>
+            <a:ext cx="3566160" cy="3291840"/>
+          </a:xfrm>
+          <a:prstGeom prst="rect">
+            <a:avLst/>
+          </a:prstGeom>
+          <a:solidFill>
+            <a:srgbClr val="B06A2C"/>
+          </a:solidFill>
+          <a:ln>
+            <a:noFill/>
+          </a:ln>
+          <a:effectLst/>
+        </p:spPr>
+        <p:style>
+          <a:lnRef idx="1">
+            <a:schemeClr val="accent1"/>
+          </a:lnRef>
+          <a:fillRef idx="3">
+            <a:schemeClr val="accent1"/>
+          </a:fillRef>
+          <a:effectRef idx="2">
+            <a:schemeClr val="accent1"/>
+          </a:effectRef>
+          <a:fontRef idx="minor">
+            <a:schemeClr val="lt1"/>
+          </a:fontRef>
+        </p:style>
+        <p:txBody>
+          <a:bodyPr rtlCol="0" anchor="ctr"/>
+          <a:lstStyle/>
+          <a:p>
+            <a:pPr algn="ctr"/>
+          </a:p>
+        </p:txBody>
+      </p:sp>
+      <p:sp>
+        <p:nvSpPr>
+          <p:cNvPr id="6" name="TextBox 5"/>
+          <p:cNvSpPr txBox="1"/>
+          <p:nvPr/>
+        </p:nvSpPr>
+        <p:spPr>
+          <a:xfrm>
+            <a:off x="777240" y="1737360"/>
+            <a:ext cx="3200400" cy="548640"/>
+          </a:xfrm>
+          <a:prstGeom prst="rect">
+            <a:avLst/>
+          </a:prstGeom>
+          <a:noFill/>
+        </p:spPr>
+        <p:txBody>
+          <a:bodyPr wrap="square">
+            <a:spAutoFit/>
+          </a:bodyPr>
+          <a:lstStyle/>
+          <a:p>
+            <a:pPr algn="l">
+              <a:spcAft>
+                <a:spcPts val="400"/>
+              </a:spcAft>
+            </a:pPr>
+            <a:r>
+              <a:rPr sz="1800" b="1">
+                <a:solidFill>
+                  <a:srgbClr val="FFFFFF"/>
+                </a:solidFill>
+                <a:latin typeface="Calibri"/>
+              </a:rPr>
+              <a:t>weather_bronze</a:t>
+            </a:r>
+          </a:p>
+        </p:txBody>
+      </p:sp>
+      <p:sp>
+        <p:nvSpPr>
+          <p:cNvPr id="7" name="TextBox 6"/>
+          <p:cNvSpPr txBox="1"/>
+          <p:nvPr/>
+        </p:nvSpPr>
+        <p:spPr>
+          <a:xfrm>
+            <a:off x="777240" y="2468880"/>
+            <a:ext cx="3200400" cy="2194560"/>
+          </a:xfrm>
+          <a:prstGeom prst="rect">
+            <a:avLst/>
+          </a:prstGeom>
+          <a:noFill/>
+        </p:spPr>
+        <p:txBody>
+          <a:bodyPr wrap="square">
+            <a:spAutoFit/>
+          </a:bodyPr>
+          <a:lstStyle/>
+          <a:p>
+            <a:pPr algn="l">
+              <a:spcAft>
+                <a:spcPts val="400"/>
+              </a:spcAft>
+            </a:pPr>
+            <a:r>
+              <a:rPr sz="1400" b="0">
+                <a:solidFill>
+                  <a:srgbClr val="FFFFFF"/>
+                </a:solidFill>
+                <a:latin typeface="Calibri"/>
+              </a:rPr>
+              <a:t>nasa_power · dmc · dgf</a:t>
+            </a:r>
+          </a:p>
+          <a:p>
+            <a:pPr algn="l">
+              <a:spcAft>
+                <a:spcPts val="400"/>
+              </a:spcAft>
+            </a:pPr>
+            <a:r>
+              <a:rPr sz="1400" b="0">
+                <a:solidFill>
+                  <a:srgbClr val="FFFFFF"/>
+                </a:solidFill>
+                <a:latin typeface="Calibri"/>
+              </a:rPr>
+              <a:t>+ all_sources (882k)</a:t>
+            </a:r>
+          </a:p>
+          <a:p>
+            <a:pPr algn="l">
+              <a:spcAft>
+                <a:spcPts val="400"/>
+              </a:spcAft>
+            </a:pPr>
+            <a:r>
+              <a:rPr sz="1400" b="0">
+                <a:solidFill>
+                  <a:srgbClr val="FFFFFF"/>
+                </a:solidFill>
+                <a:latin typeface="Calibri"/>
+              </a:rPr>
+              <a:t>raw ingested</a:t>
+            </a:r>
+          </a:p>
+        </p:txBody>
+      </p:sp>
+      <p:sp>
+        <p:nvSpPr>
+          <p:cNvPr id="8" name="Rectangle 7"/>
+          <p:cNvSpPr/>
+          <p:nvPr/>
+        </p:nvSpPr>
+        <p:spPr>
+          <a:xfrm>
+            <a:off x="4297679" y="1554480"/>
+            <a:ext cx="3566160" cy="3291840"/>
+          </a:xfrm>
+          <a:prstGeom prst="rect">
+            <a:avLst/>
+          </a:prstGeom>
+          <a:solidFill>
+            <a:srgbClr val="555B66"/>
+          </a:solidFill>
+          <a:ln>
+            <a:noFill/>
+          </a:ln>
+          <a:effectLst/>
+        </p:spPr>
+        <p:style>
+          <a:lnRef idx="1">
+            <a:schemeClr val="accent1"/>
+          </a:lnRef>
+          <a:fillRef idx="3">
+            <a:schemeClr val="accent1"/>
+          </a:fillRef>
+          <a:effectRef idx="2">
+            <a:schemeClr val="accent1"/>
+          </a:effectRef>
+          <a:fontRef idx="minor">
+            <a:schemeClr val="lt1"/>
+          </a:fontRef>
+        </p:style>
+        <p:txBody>
+          <a:bodyPr rtlCol="0" anchor="ctr"/>
+          <a:lstStyle/>
+          <a:p>
+            <a:pPr algn="ctr"/>
+          </a:p>
+        </p:txBody>
+      </p:sp>
+      <p:sp>
+        <p:nvSpPr>
+          <p:cNvPr id="9" name="TextBox 8"/>
+          <p:cNvSpPr txBox="1"/>
+          <p:nvPr/>
+        </p:nvSpPr>
+        <p:spPr>
+          <a:xfrm>
+            <a:off x="4526279" y="1737360"/>
+            <a:ext cx="3200400" cy="548640"/>
+          </a:xfrm>
+          <a:prstGeom prst="rect">
+            <a:avLst/>
+          </a:prstGeom>
+          <a:noFill/>
+        </p:spPr>
+        <p:txBody>
+          <a:bodyPr wrap="square">
+            <a:spAutoFit/>
+          </a:bodyPr>
+          <a:lstStyle/>
+          <a:p>
+            <a:pPr algn="l">
+              <a:spcAft>
+                <a:spcPts val="400"/>
+              </a:spcAft>
+            </a:pPr>
+            <a:r>
+              <a:rPr sz="1800" b="1">
+                <a:solidFill>
+                  <a:srgbClr val="FFFFFF"/>
+                </a:solidFill>
+                <a:latin typeface="Calibri"/>
+              </a:rPr>
+              <a:t>weather_silver</a:t>
+            </a:r>
+          </a:p>
+        </p:txBody>
+      </p:sp>
+      <p:sp>
+        <p:nvSpPr>
+          <p:cNvPr id="10" name="TextBox 9"/>
+          <p:cNvSpPr txBox="1"/>
+          <p:nvPr/>
+        </p:nvSpPr>
+        <p:spPr>
+          <a:xfrm>
+            <a:off x="4526279" y="2468880"/>
+            <a:ext cx="3200400" cy="2194560"/>
+          </a:xfrm>
+          <a:prstGeom prst="rect">
+            <a:avLst/>
+          </a:prstGeom>
+          <a:noFill/>
+        </p:spPr>
+        <p:txBody>
+          <a:bodyPr wrap="square">
+            <a:spAutoFit/>
+          </a:bodyPr>
+          <a:lstStyle/>
+          <a:p>
+            <a:pPr algn="l">
+              <a:spcAft>
+                <a:spcPts val="400"/>
+              </a:spcAft>
+            </a:pPr>
+            <a:r>
+              <a:rPr sz="1400" b="0">
+                <a:solidFill>
+                  <a:srgbClr val="FFFFFF"/>
+                </a:solidFill>
+                <a:latin typeface="Calibri"/>
+              </a:rPr>
+              <a:t>nasa dim/fact · dmc dim/fact</a:t>
+            </a:r>
+          </a:p>
+          <a:p>
+            <a:pPr algn="l">
+              <a:spcAft>
+                <a:spcPts val="400"/>
+              </a:spcAft>
+            </a:pPr>
+            <a:r>
+              <a:rPr sz="1400" b="0">
+                <a:solidFill>
+                  <a:srgbClr val="FFFFFF"/>
+                </a:solidFill>
+                <a:latin typeface="Calibri"/>
+              </a:rPr>
+              <a:t>dgf · + all_sources (881k)</a:t>
+            </a:r>
+          </a:p>
+          <a:p>
+            <a:pPr algn="l">
+              <a:spcAft>
+                <a:spcPts val="400"/>
+              </a:spcAft>
+            </a:pPr>
+            <a:r>
+              <a:rPr sz="1400" b="0">
+                <a:solidFill>
+                  <a:srgbClr val="FFFFFF"/>
+                </a:solidFill>
+                <a:latin typeface="Calibri"/>
+              </a:rPr>
+              <a:t>cleaned + modeled</a:t>
+            </a:r>
+          </a:p>
+        </p:txBody>
+      </p:sp>
+      <p:sp>
+        <p:nvSpPr>
+          <p:cNvPr id="11" name="Rectangle 10"/>
+          <p:cNvSpPr/>
+          <p:nvPr/>
+        </p:nvSpPr>
+        <p:spPr>
+          <a:xfrm>
+            <a:off x="8046719" y="1554480"/>
+            <a:ext cx="3566160" cy="3291840"/>
+          </a:xfrm>
+          <a:prstGeom prst="rect">
+            <a:avLst/>
+          </a:prstGeom>
+          <a:solidFill>
+            <a:srgbClr val="C9A227"/>
+          </a:solidFill>
+          <a:ln>
+            <a:noFill/>
+          </a:ln>
+          <a:effectLst/>
+        </p:spPr>
+        <p:style>
+          <a:lnRef idx="1">
+            <a:schemeClr val="accent1"/>
+          </a:lnRef>
+          <a:fillRef idx="3">
+            <a:schemeClr val="accent1"/>
+          </a:fillRef>
+          <a:effectRef idx="2">
+            <a:schemeClr val="accent1"/>
+          </a:effectRef>
+          <a:fontRef idx="minor">
+            <a:schemeClr val="lt1"/>
+          </a:fontRef>
+        </p:style>
+        <p:txBody>
+          <a:bodyPr rtlCol="0" anchor="ctr"/>
+          <a:lstStyle/>
+          <a:p>
+            <a:pPr algn="ctr"/>
+          </a:p>
+        </p:txBody>
+      </p:sp>
+      <p:sp>
+        <p:nvSpPr>
+          <p:cNvPr id="12" name="TextBox 11"/>
+          <p:cNvSpPr txBox="1"/>
+          <p:nvPr/>
+        </p:nvSpPr>
+        <p:spPr>
+          <a:xfrm>
+            <a:off x="8275319" y="1737360"/>
+            <a:ext cx="3200400" cy="548640"/>
+          </a:xfrm>
+          <a:prstGeom prst="rect">
+            <a:avLst/>
+          </a:prstGeom>
+          <a:noFill/>
+        </p:spPr>
+        <p:txBody>
+          <a:bodyPr wrap="square">
+            <a:spAutoFit/>
+          </a:bodyPr>
+          <a:lstStyle/>
+          <a:p>
+            <a:pPr algn="l">
+              <a:spcAft>
+                <a:spcPts val="400"/>
+              </a:spcAft>
+            </a:pPr>
+            <a:r>
+              <a:rPr sz="1800" b="1">
+                <a:solidFill>
+                  <a:srgbClr val="FFFFFF"/>
+                </a:solidFill>
+                <a:latin typeface="Calibri"/>
+              </a:rPr>
+              <a:t>weather_gold</a:t>
+            </a:r>
+          </a:p>
+        </p:txBody>
+      </p:sp>
+      <p:sp>
+        <p:nvSpPr>
+          <p:cNvPr id="13" name="TextBox 12"/>
+          <p:cNvSpPr txBox="1"/>
+          <p:nvPr/>
+        </p:nvSpPr>
+        <p:spPr>
+          <a:xfrm>
+            <a:off x="8275319" y="2468880"/>
+            <a:ext cx="3200400" cy="2194560"/>
+          </a:xfrm>
+          <a:prstGeom prst="rect">
+            <a:avLst/>
+          </a:prstGeom>
+          <a:noFill/>
+        </p:spPr>
+        <p:txBody>
+          <a:bodyPr wrap="square">
+            <a:spAutoFit/>
+          </a:bodyPr>
+          <a:lstStyle/>
+          <a:p>
+            <a:pPr algn="l">
+              <a:spcAft>
+                <a:spcPts val="400"/>
+              </a:spcAft>
+            </a:pPr>
+            <a:r>
+              <a:rPr sz="1400" b="0">
+                <a:solidFill>
+                  <a:srgbClr val="FFFFFF"/>
+                </a:solidFill>
+                <a:latin typeface="Calibri"/>
+              </a:rPr>
+              <a:t>per-source KPIs</a:t>
+            </a:r>
+          </a:p>
+          <a:p>
+            <a:pPr algn="l">
+              <a:spcAft>
+                <a:spcPts val="400"/>
+              </a:spcAft>
+            </a:pPr>
+            <a:r>
+              <a:rPr sz="1400" b="0">
+                <a:solidFill>
+                  <a:srgbClr val="FFFFFF"/>
+                </a:solidFill>
+                <a:latin typeface="Calibri"/>
+              </a:rPr>
+              <a:t>+ all_sources_kpi</a:t>
+            </a:r>
+          </a:p>
+          <a:p>
+            <a:pPr algn="l">
+              <a:spcAft>
+                <a:spcPts val="400"/>
+              </a:spcAft>
+            </a:pPr>
+            <a:r>
+              <a:rPr sz="1400" b="0">
+                <a:solidFill>
+                  <a:srgbClr val="FFFFFF"/>
+                </a:solidFill>
+                <a:latin typeface="Calibri"/>
+              </a:rPr>
+              <a:t>chile/world daily (2yr + YTD)</a:t>
+            </a:r>
+          </a:p>
+        </p:txBody>
+      </p:sp>
+      <p:sp>
+        <p:nvSpPr>
+          <p:cNvPr id="14" name="TextBox 13"/>
+          <p:cNvSpPr txBox="1"/>
+          <p:nvPr/>
+        </p:nvSpPr>
+        <p:spPr>
+          <a:xfrm>
+            <a:off x="548640" y="5074920"/>
+            <a:ext cx="10972800" cy="914400"/>
+          </a:xfrm>
+          <a:prstGeom prst="rect">
+            <a:avLst/>
+          </a:prstGeom>
+          <a:noFill/>
+        </p:spPr>
+        <p:txBody>
+          <a:bodyPr wrap="square">
+            <a:spAutoFit/>
+          </a:bodyPr>
+          <a:lstStyle/>
+          <a:p>
+            <a:pPr algn="l">
+              <a:spcAft>
+                <a:spcPts val="400"/>
+              </a:spcAft>
+            </a:pPr>
+            <a:r>
+              <a:rPr sz="1300" b="0">
+                <a:solidFill>
+                  <a:srgbClr val="555B66"/>
+                </a:solidFill>
+                <a:latin typeface="Calibri"/>
+              </a:rPr>
+              <a:t>Consolidated shape: source, location, resource, lat, lon, momento, ghi, temperatura, humedad, presion, viento, ...</a:t>
+            </a:r>
+          </a:p>
+          <a:p>
+            <a:pPr algn="l">
+              <a:spcAft>
+                <a:spcPts val="400"/>
+              </a:spcAft>
+            </a:pPr>
+            <a:r>
+              <a:rPr sz="1300" b="0">
+                <a:solidFill>
+                  <a:srgbClr val="555B66"/>
+                </a:solidFill>
+                <a:latin typeface="Calibri"/>
+              </a:rPr>
+              <a:t>Schemas &amp; key tables carry Unity Catalog COMMENTs; symmetric naming by region/period.</a:t>
+            </a:r>
+          </a:p>
+        </p:txBody>
+      </p:sp>
     </p:spTree>
   </p:cSld>
   <p:clrMapOvr>
@@ -3460,14 +5173,58 @@
       <p:grpSpPr/>
       <p:sp>
         <p:nvSpPr>
-          <p:cNvPr id="2" name="TextBox 1"/>
+          <p:cNvPr id="2" name="Rectangle 1"/>
+          <p:cNvSpPr/>
+          <p:nvPr/>
+        </p:nvSpPr>
+        <p:spPr>
+          <a:xfrm>
+            <a:off x="0" y="0"/>
+            <a:ext cx="12191695" cy="1051560"/>
+          </a:xfrm>
+          <a:prstGeom prst="rect">
+            <a:avLst/>
+          </a:prstGeom>
+          <a:solidFill>
+            <a:srgbClr val="1B2A4A"/>
+          </a:solidFill>
+          <a:ln>
+            <a:noFill/>
+          </a:ln>
+          <a:effectLst/>
+        </p:spPr>
+        <p:style>
+          <a:lnRef idx="1">
+            <a:schemeClr val="accent1"/>
+          </a:lnRef>
+          <a:fillRef idx="3">
+            <a:schemeClr val="accent1"/>
+          </a:fillRef>
+          <a:effectRef idx="2">
+            <a:schemeClr val="accent1"/>
+          </a:effectRef>
+          <a:fontRef idx="minor">
+            <a:schemeClr val="lt1"/>
+          </a:fontRef>
+        </p:style>
+        <p:txBody>
+          <a:bodyPr rtlCol="0" anchor="ctr"/>
+          <a:lstStyle/>
+          <a:p>
+            <a:pPr algn="ctr"/>
+          </a:p>
+        </p:txBody>
+      </p:sp>
+      <p:sp>
+        <p:nvSpPr>
+          <p:cNvPr id="3" name="TextBox 2"/>
           <p:cNvSpPr txBox="1"/>
           <p:nvPr/>
         </p:nvSpPr>
         <p:spPr>
           <a:xfrm>
-            <a:off x="548640" y="365760"/>
-            <a:ext cx="11064240" cy="914400"/>
+            <a:off x="457200" y="164592"/>
+            <a:ext cx="11247120" cy="731520"/>
           </a:xfrm>
           <a:prstGeom prst="rect">
             <a:avLst/>
@@ -3480,29 +5237,33 @@
           </a:bodyPr>
           <a:lstStyle/>
           <a:p>
-            <a:pPr>
-              <a:defRPr sz="3000" b="1">
-                <a:solidFill>
-                  <a:srgbClr val="059669"/>
-                </a:solidFill>
-              </a:defRPr>
+            <a:pPr algn="l">
+              <a:spcAft>
+                <a:spcPts val="400"/>
+              </a:spcAft>
             </a:pPr>
             <a:r>
-              <a:t>Weather NASA - star schema + marts + dashboard</a:t>
-            </a:r>
-          </a:p>
-        </p:txBody>
-      </p:sp>
-      <p:sp>
-        <p:nvSpPr>
-          <p:cNvPr id="3" name="TextBox 2"/>
+              <a:rPr sz="2600" b="1">
+                <a:solidFill>
+                  <a:srgbClr val="FFFFFF"/>
+                </a:solidFill>
+                <a:latin typeface="Calibri"/>
+              </a:rPr>
+              <a:t>End-to-end data flow</a:t>
+            </a:r>
+          </a:p>
+        </p:txBody>
+      </p:sp>
+      <p:sp>
+        <p:nvSpPr>
+          <p:cNvPr id="4" name="TextBox 3"/>
           <p:cNvSpPr txBox="1"/>
           <p:nvPr/>
         </p:nvSpPr>
         <p:spPr>
           <a:xfrm>
-            <a:off x="640080" y="1554480"/>
-            <a:ext cx="10881360" cy="4937760"/>
+            <a:off x="457200" y="658368"/>
+            <a:ext cx="11247120" cy="365760"/>
           </a:xfrm>
           <a:prstGeom prst="rect">
             <a:avLst/>
@@ -3515,67 +5276,47 @@
           </a:bodyPr>
           <a:lstStyle/>
           <a:p>
-            <a:pPr>
+            <a:pPr algn="l">
               <a:spcAft>
-                <a:spcPts val="600"/>
+                <a:spcPts val="400"/>
               </a:spcAft>
-              <a:defRPr sz="1800">
-                <a:solidFill>
-                  <a:srgbClr val="0F172A"/>
-                </a:solidFill>
-              </a:defRPr>
             </a:pPr>
             <a:r>
-              <a:t>Silver STAR: dim_plant + fact_weather_hourly (876,720 rows, 10 years, DQ)</a:t>
-            </a:r>
-          </a:p>
-          <a:p>
-            <a:pPr>
-              <a:spcAft>
-                <a:spcPts val="600"/>
-              </a:spcAft>
-              <a:defRPr sz="1800">
-                <a:solidFill>
-                  <a:srgbClr val="0F172A"/>
-                </a:solidFill>
-              </a:defRPr>
-            </a:pPr>
-            <a:r>
-              <a:t>Gold marts: resource KPI + daily (36,530) + monthly (1,200)</a:t>
-            </a:r>
-          </a:p>
-          <a:p>
-            <a:pPr>
-              <a:spcAft>
-                <a:spcPts val="600"/>
-              </a:spcAft>
-              <a:defRPr sz="1800">
-                <a:solidFill>
-                  <a:srgbClr val="0F172A"/>
-                </a:solidFill>
-              </a:defRPr>
-            </a:pPr>
-            <a:r>
-              <a:t>AI/BI dashboard: monthly GHI/wind per plant + KPI table</a:t>
-            </a:r>
-          </a:p>
-          <a:p>
-            <a:pPr>
-              <a:spcAft>
-                <a:spcPts val="600"/>
-              </a:spcAft>
-              <a:defRPr sz="1800">
-                <a:solidFill>
-                  <a:srgbClr val="0F172A"/>
-                </a:solidFill>
-              </a:defRPr>
-            </a:pPr>
-            <a:r>
-              <a:t>Reproducible as DLT pipeline weather_nasa (bundle validate OK)</a:t>
-            </a:r>
-          </a:p>
-        </p:txBody>
-      </p:sp>
+              <a:rPr sz="1200" b="0">
+                <a:solidFill>
+                  <a:srgbClr val="C7D2E6"/>
+                </a:solidFill>
+                <a:latin typeface="Calibri"/>
+              </a:rPr>
+              <a:t>Fetch → UC Volume → Auto Loader → Bronze → Silver → Gold → Dashboards</a:t>
+            </a:r>
+          </a:p>
+        </p:txBody>
+      </p:sp>
+      <p:pic>
+        <p:nvPicPr>
+          <p:cNvPr id="5" name="Picture 4" descr="dataflow.png"/>
+          <p:cNvPicPr>
+            <a:picLocks noChangeAspect="1"/>
+          </p:cNvPicPr>
+          <p:nvPr/>
+        </p:nvPicPr>
+        <p:blipFill>
+          <a:blip r:embed="rId2"/>
+          <a:stretch>
+            <a:fillRect/>
+          </a:stretch>
+        </p:blipFill>
+        <p:spPr>
+          <a:xfrm>
+            <a:off x="640080" y="1325880"/>
+            <a:ext cx="10972800" cy="7143366"/>
+          </a:xfrm>
+          <a:prstGeom prst="rect">
+            <a:avLst/>
+          </a:prstGeom>
+        </p:spPr>
+      </p:pic>
     </p:spTree>
   </p:cSld>
   <p:clrMapOvr>
@@ -3596,14 +5337,58 @@
       <p:grpSpPr/>
       <p:sp>
         <p:nvSpPr>
-          <p:cNvPr id="2" name="TextBox 1"/>
+          <p:cNvPr id="2" name="Rectangle 1"/>
+          <p:cNvSpPr/>
+          <p:nvPr/>
+        </p:nvSpPr>
+        <p:spPr>
+          <a:xfrm>
+            <a:off x="0" y="0"/>
+            <a:ext cx="12191695" cy="1051560"/>
+          </a:xfrm>
+          <a:prstGeom prst="rect">
+            <a:avLst/>
+          </a:prstGeom>
+          <a:solidFill>
+            <a:srgbClr val="1B2A4A"/>
+          </a:solidFill>
+          <a:ln>
+            <a:noFill/>
+          </a:ln>
+          <a:effectLst/>
+        </p:spPr>
+        <p:style>
+          <a:lnRef idx="1">
+            <a:schemeClr val="accent1"/>
+          </a:lnRef>
+          <a:fillRef idx="3">
+            <a:schemeClr val="accent1"/>
+          </a:fillRef>
+          <a:effectRef idx="2">
+            <a:schemeClr val="accent1"/>
+          </a:effectRef>
+          <a:fontRef idx="minor">
+            <a:schemeClr val="lt1"/>
+          </a:fontRef>
+        </p:style>
+        <p:txBody>
+          <a:bodyPr rtlCol="0" anchor="ctr"/>
+          <a:lstStyle/>
+          <a:p>
+            <a:pPr algn="ctr"/>
+          </a:p>
+        </p:txBody>
+      </p:sp>
+      <p:sp>
+        <p:nvSpPr>
+          <p:cNvPr id="3" name="TextBox 2"/>
           <p:cNvSpPr txBox="1"/>
           <p:nvPr/>
         </p:nvSpPr>
         <p:spPr>
           <a:xfrm>
-            <a:off x="548640" y="365760"/>
-            <a:ext cx="11064240" cy="914400"/>
+            <a:off x="457200" y="164592"/>
+            <a:ext cx="11247120" cy="731520"/>
           </a:xfrm>
           <a:prstGeom prst="rect">
             <a:avLst/>
@@ -3616,29 +5401,33 @@
           </a:bodyPr>
           <a:lstStyle/>
           <a:p>
-            <a:pPr>
-              <a:defRPr sz="3000" b="1">
-                <a:solidFill>
-                  <a:srgbClr val="059669"/>
-                </a:solidFill>
-              </a:defRPr>
+            <a:pPr algn="l">
+              <a:spcAft>
+                <a:spcPts val="400"/>
+              </a:spcAft>
             </a:pPr>
             <a:r>
-              <a:t>Results (verified in dev)</a:t>
-            </a:r>
-          </a:p>
-        </p:txBody>
-      </p:sp>
-      <p:sp>
-        <p:nvSpPr>
-          <p:cNvPr id="3" name="TextBox 2"/>
+              <a:rPr sz="2600" b="1">
+                <a:solidFill>
+                  <a:srgbClr val="FFFFFF"/>
+                </a:solidFill>
+                <a:latin typeface="Calibri"/>
+              </a:rPr>
+              <a:t>Weather medallion — tables &amp; row counts</a:t>
+            </a:r>
+          </a:p>
+        </p:txBody>
+      </p:sp>
+      <p:sp>
+        <p:nvSpPr>
+          <p:cNvPr id="4" name="TextBox 3"/>
           <p:cNvSpPr txBox="1"/>
           <p:nvPr/>
         </p:nvSpPr>
         <p:spPr>
           <a:xfrm>
-            <a:off x="640080" y="1554480"/>
-            <a:ext cx="10881360" cy="4937760"/>
+            <a:off x="457200" y="658368"/>
+            <a:ext cx="11247120" cy="365760"/>
           </a:xfrm>
           <a:prstGeom prst="rect">
             <a:avLst/>
@@ -3651,67 +5440,47 @@
           </a:bodyPr>
           <a:lstStyle/>
           <a:p>
-            <a:pPr>
+            <a:pPr algn="l">
               <a:spcAft>
-                <a:spcPts val="600"/>
+                <a:spcPts val="400"/>
               </a:spcAft>
-              <a:defRPr sz="1800">
-                <a:solidFill>
-                  <a:srgbClr val="0F172A"/>
-                </a:solidFill>
-              </a:defRPr>
             </a:pPr>
             <a:r>
-              <a:t>Medallion end-to-end for all three domains</a:t>
-            </a:r>
-          </a:p>
-          <a:p>
-            <a:pPr>
-              <a:spcAft>
-                <a:spcPts val="600"/>
-              </a:spcAft>
-              <a:defRPr sz="1800">
-                <a:solidFill>
-                  <a:srgbClr val="0F172A"/>
-                </a:solidFill>
-              </a:defRPr>
-            </a:pPr>
-            <a:r>
-              <a:t>Weather: 876,720-row 10-year load; Atacama highest irradiance (valid)</a:t>
-            </a:r>
-          </a:p>
-          <a:p>
-            <a:pPr>
-              <a:spcAft>
-                <a:spcPts val="600"/>
-              </a:spcAft>
-              <a:defRPr sz="1800">
-                <a:solidFill>
-                  <a:srgbClr val="0F172A"/>
-                </a:solidFill>
-              </a:defRPr>
-            </a:pPr>
-            <a:r>
-              <a:t>Resource: real per-plant generation (coord/real/reduc)</a:t>
-            </a:r>
-          </a:p>
-          <a:p>
-            <a:pPr>
-              <a:spcAft>
-                <a:spcPts val="600"/>
-              </a:spcAft>
-              <a:defRPr sz="1800">
-                <a:solidFill>
-                  <a:srgbClr val="0F172A"/>
-                </a:solidFill>
-              </a:defRPr>
-            </a:pPr>
-            <a:r>
-              <a:t>Conglomerate: Chile-vs-World renewables lead +19 -&gt; +38 (2017-2024)</a:t>
-            </a:r>
-          </a:p>
-        </p:txBody>
-      </p:sp>
+              <a:rPr sz="1200" b="0">
+                <a:solidFill>
+                  <a:srgbClr val="C7D2E6"/>
+                </a:solidFill>
+                <a:latin typeface="Calibri"/>
+              </a:rPr>
+              <a:t>dev.weather_bronze / _silver / _gold · per-source + consolidated all_sources</a:t>
+            </a:r>
+          </a:p>
+        </p:txBody>
+      </p:sp>
+      <p:pic>
+        <p:nvPicPr>
+          <p:cNvPr id="5" name="Picture 4" descr="medallion-map.png"/>
+          <p:cNvPicPr>
+            <a:picLocks noChangeAspect="1"/>
+          </p:cNvPicPr>
+          <p:nvPr/>
+        </p:nvPicPr>
+        <p:blipFill>
+          <a:blip r:embed="rId2"/>
+          <a:stretch>
+            <a:fillRect/>
+          </a:stretch>
+        </p:blipFill>
+        <p:spPr>
+          <a:xfrm>
+            <a:off x="640080" y="1325880"/>
+            <a:ext cx="10972800" cy="5458691"/>
+          </a:xfrm>
+          <a:prstGeom prst="rect">
+            <a:avLst/>
+          </a:prstGeom>
+        </p:spPr>
+      </p:pic>
     </p:spTree>
   </p:cSld>
   <p:clrMapOvr>
@@ -3732,14 +5501,58 @@
       <p:grpSpPr/>
       <p:sp>
         <p:nvSpPr>
-          <p:cNvPr id="2" name="TextBox 1"/>
+          <p:cNvPr id="2" name="Rectangle 1"/>
+          <p:cNvSpPr/>
+          <p:nvPr/>
+        </p:nvSpPr>
+        <p:spPr>
+          <a:xfrm>
+            <a:off x="0" y="0"/>
+            <a:ext cx="12191695" cy="1051560"/>
+          </a:xfrm>
+          <a:prstGeom prst="rect">
+            <a:avLst/>
+          </a:prstGeom>
+          <a:solidFill>
+            <a:srgbClr val="1B2A4A"/>
+          </a:solidFill>
+          <a:ln>
+            <a:noFill/>
+          </a:ln>
+          <a:effectLst/>
+        </p:spPr>
+        <p:style>
+          <a:lnRef idx="1">
+            <a:schemeClr val="accent1"/>
+          </a:lnRef>
+          <a:fillRef idx="3">
+            <a:schemeClr val="accent1"/>
+          </a:fillRef>
+          <a:effectRef idx="2">
+            <a:schemeClr val="accent1"/>
+          </a:effectRef>
+          <a:fontRef idx="minor">
+            <a:schemeClr val="lt1"/>
+          </a:fontRef>
+        </p:style>
+        <p:txBody>
+          <a:bodyPr rtlCol="0" anchor="ctr"/>
+          <a:lstStyle/>
+          <a:p>
+            <a:pPr algn="ctr"/>
+          </a:p>
+        </p:txBody>
+      </p:sp>
+      <p:sp>
+        <p:nvSpPr>
+          <p:cNvPr id="3" name="TextBox 2"/>
           <p:cNvSpPr txBox="1"/>
           <p:nvPr/>
         </p:nvSpPr>
         <p:spPr>
           <a:xfrm>
-            <a:off x="548640" y="365760"/>
-            <a:ext cx="11064240" cy="914400"/>
+            <a:off x="457200" y="164592"/>
+            <a:ext cx="11247120" cy="731520"/>
           </a:xfrm>
           <a:prstGeom prst="rect">
             <a:avLst/>
@@ -3752,29 +5565,77 @@
           </a:bodyPr>
           <a:lstStyle/>
           <a:p>
-            <a:pPr>
-              <a:defRPr sz="3000" b="1">
-                <a:solidFill>
-                  <a:srgbClr val="0284C7"/>
-                </a:solidFill>
-              </a:defRPr>
+            <a:pPr algn="l">
+              <a:spcAft>
+                <a:spcPts val="400"/>
+              </a:spcAft>
             </a:pPr>
             <a:r>
-              <a:t>Governance, quality &amp; observability</a:t>
-            </a:r>
-          </a:p>
-        </p:txBody>
-      </p:sp>
-      <p:sp>
-        <p:nvSpPr>
-          <p:cNvPr id="3" name="TextBox 2"/>
+              <a:rPr sz="2600" b="1">
+                <a:solidFill>
+                  <a:srgbClr val="FFFFFF"/>
+                </a:solidFill>
+                <a:latin typeface="Calibri"/>
+              </a:rPr>
+              <a:t>AI/BI dashboards (Lakeview)</a:t>
+            </a:r>
+          </a:p>
+        </p:txBody>
+      </p:sp>
+      <p:sp>
+        <p:nvSpPr>
+          <p:cNvPr id="4" name="Rectangle 3"/>
+          <p:cNvSpPr/>
+          <p:nvPr/>
+        </p:nvSpPr>
+        <p:spPr>
+          <a:xfrm>
+            <a:off x="457200" y="1536192"/>
+            <a:ext cx="164592" cy="960120"/>
+          </a:xfrm>
+          <a:prstGeom prst="rect">
+            <a:avLst/>
+          </a:prstGeom>
+          <a:solidFill>
+            <a:srgbClr val="2E5BA8"/>
+          </a:solidFill>
+          <a:ln>
+            <a:noFill/>
+          </a:ln>
+          <a:effectLst/>
+        </p:spPr>
+        <p:style>
+          <a:lnRef idx="1">
+            <a:schemeClr val="accent1"/>
+          </a:lnRef>
+          <a:fillRef idx="3">
+            <a:schemeClr val="accent1"/>
+          </a:fillRef>
+          <a:effectRef idx="2">
+            <a:schemeClr val="accent1"/>
+          </a:effectRef>
+          <a:fontRef idx="minor">
+            <a:schemeClr val="lt1"/>
+          </a:fontRef>
+        </p:style>
+        <p:txBody>
+          <a:bodyPr rtlCol="0" anchor="ctr"/>
+          <a:lstStyle/>
+          <a:p>
+            <a:pPr algn="ctr"/>
+          </a:p>
+        </p:txBody>
+      </p:sp>
+      <p:sp>
+        <p:nvSpPr>
+          <p:cNvPr id="5" name="TextBox 4"/>
           <p:cNvSpPr txBox="1"/>
           <p:nvPr/>
         </p:nvSpPr>
         <p:spPr>
           <a:xfrm>
-            <a:off x="640080" y="1554480"/>
-            <a:ext cx="10881360" cy="4937760"/>
+            <a:off x="777240" y="1463040"/>
+            <a:ext cx="10972800" cy="457200"/>
           </a:xfrm>
           <a:prstGeom prst="rect">
             <a:avLst/>
@@ -3787,67 +5648,756 @@
           </a:bodyPr>
           <a:lstStyle/>
           <a:p>
-            <a:pPr>
+            <a:pPr algn="l">
               <a:spcAft>
-                <a:spcPts val="600"/>
+                <a:spcPts val="400"/>
               </a:spcAft>
-              <a:defRPr sz="1800">
-                <a:solidFill>
-                  <a:srgbClr val="0F172A"/>
-                </a:solidFill>
-              </a:defRPr>
             </a:pPr>
             <a:r>
-              <a:t>Data contracts per medallion step + data glossary</a:t>
-            </a:r>
-          </a:p>
-          <a:p>
-            <a:pPr>
+              <a:rPr sz="1600" b="1">
+                <a:solidFill>
+                  <a:srgbClr val="1B2A4A"/>
+                </a:solidFill>
+                <a:latin typeface="Calibri"/>
+              </a:rPr>
+              <a:t>Weather — Chile &amp; Rest of World (2 tabs)</a:t>
+            </a:r>
+          </a:p>
+        </p:txBody>
+      </p:sp>
+      <p:sp>
+        <p:nvSpPr>
+          <p:cNvPr id="6" name="TextBox 5"/>
+          <p:cNvSpPr txBox="1"/>
+          <p:nvPr/>
+        </p:nvSpPr>
+        <p:spPr>
+          <a:xfrm>
+            <a:off x="777240" y="1847088"/>
+            <a:ext cx="10972800" cy="640080"/>
+          </a:xfrm>
+          <a:prstGeom prst="rect">
+            <a:avLst/>
+          </a:prstGeom>
+          <a:noFill/>
+        </p:spPr>
+        <p:txBody>
+          <a:bodyPr wrap="square">
+            <a:spAutoFit/>
+          </a:bodyPr>
+          <a:lstStyle/>
+          <a:p>
+            <a:pPr algn="l">
               <a:spcAft>
-                <a:spcPts val="600"/>
+                <a:spcPts val="400"/>
               </a:spcAft>
-              <a:defRPr sz="1800">
-                <a:solidFill>
-                  <a:srgbClr val="0F172A"/>
-                </a:solidFill>
-              </a:defRPr>
             </a:pPr>
             <a:r>
-              <a:t>DLT expectations enforce quality in-pipeline</a:t>
-            </a:r>
-          </a:p>
-          <a:p>
-            <a:pPr>
+              <a:rPr sz="1300" b="0">
+                <a:solidFill>
+                  <a:srgbClr val="22262E"/>
+                </a:solidFill>
+                <a:latin typeface="Calibri"/>
+              </a:rPr>
+              <a:t>Seasonality, trends, max/min/means of temperature, GHI, pressure, wind; per-location &amp; per-city; hemisphere inversion (12 world cities).</a:t>
+            </a:r>
+          </a:p>
+        </p:txBody>
+      </p:sp>
+      <p:sp>
+        <p:nvSpPr>
+          <p:cNvPr id="7" name="Rectangle 6"/>
+          <p:cNvSpPr/>
+          <p:nvPr/>
+        </p:nvSpPr>
+        <p:spPr>
+          <a:xfrm>
+            <a:off x="457200" y="2743200"/>
+            <a:ext cx="164592" cy="960120"/>
+          </a:xfrm>
+          <a:prstGeom prst="rect">
+            <a:avLst/>
+          </a:prstGeom>
+          <a:solidFill>
+            <a:srgbClr val="2E5BA8"/>
+          </a:solidFill>
+          <a:ln>
+            <a:noFill/>
+          </a:ln>
+          <a:effectLst/>
+        </p:spPr>
+        <p:style>
+          <a:lnRef idx="1">
+            <a:schemeClr val="accent1"/>
+          </a:lnRef>
+          <a:fillRef idx="3">
+            <a:schemeClr val="accent1"/>
+          </a:fillRef>
+          <a:effectRef idx="2">
+            <a:schemeClr val="accent1"/>
+          </a:effectRef>
+          <a:fontRef idx="minor">
+            <a:schemeClr val="lt1"/>
+          </a:fontRef>
+        </p:style>
+        <p:txBody>
+          <a:bodyPr rtlCol="0" anchor="ctr"/>
+          <a:lstStyle/>
+          <a:p>
+            <a:pPr algn="ctr"/>
+          </a:p>
+        </p:txBody>
+      </p:sp>
+      <p:sp>
+        <p:nvSpPr>
+          <p:cNvPr id="8" name="TextBox 7"/>
+          <p:cNvSpPr txBox="1"/>
+          <p:nvPr/>
+        </p:nvSpPr>
+        <p:spPr>
+          <a:xfrm>
+            <a:off x="777240" y="2670048"/>
+            <a:ext cx="10972800" cy="457200"/>
+          </a:xfrm>
+          <a:prstGeom prst="rect">
+            <a:avLst/>
+          </a:prstGeom>
+          <a:noFill/>
+        </p:spPr>
+        <p:txBody>
+          <a:bodyPr wrap="square">
+            <a:spAutoFit/>
+          </a:bodyPr>
+          <a:lstStyle/>
+          <a:p>
+            <a:pPr algn="l">
               <a:spcAft>
-                <a:spcPts val="600"/>
+                <a:spcPts val="400"/>
               </a:spcAft>
-              <a:defRPr sz="1800">
-                <a:solidFill>
-                  <a:srgbClr val="0F172A"/>
-                </a:solidFill>
-              </a:defRPr>
             </a:pPr>
             <a:r>
-              <a:t>Three Data-Quality Monitors on gold (profiling + drift, auto dashboards)</a:t>
-            </a:r>
-          </a:p>
-          <a:p>
-            <a:pPr>
+              <a:rPr sz="1600" b="1">
+                <a:solidFill>
+                  <a:srgbClr val="1B2A4A"/>
+                </a:solidFill>
+                <a:latin typeface="Calibri"/>
+              </a:rPr>
+              <a:t>Weather — Chile &amp; Rest of World, 2025–2026 YTD</a:t>
+            </a:r>
+          </a:p>
+        </p:txBody>
+      </p:sp>
+      <p:sp>
+        <p:nvSpPr>
+          <p:cNvPr id="9" name="TextBox 8"/>
+          <p:cNvSpPr txBox="1"/>
+          <p:nvPr/>
+        </p:nvSpPr>
+        <p:spPr>
+          <a:xfrm>
+            <a:off x="777240" y="3054096"/>
+            <a:ext cx="10972800" cy="640080"/>
+          </a:xfrm>
+          <a:prstGeom prst="rect">
+            <a:avLst/>
+          </a:prstGeom>
+          <a:noFill/>
+        </p:spPr>
+        <p:txBody>
+          <a:bodyPr wrap="square">
+            <a:spAutoFit/>
+          </a:bodyPr>
+          <a:lstStyle/>
+          <a:p>
+            <a:pPr algn="l">
               <a:spcAft>
-                <a:spcPts val="600"/>
+                <a:spcPts val="400"/>
               </a:spcAft>
-              <a:defRPr sz="1800">
-                <a:solidFill>
-                  <a:srgbClr val="0F172A"/>
-                </a:solidFill>
-              </a:defRPr>
             </a:pPr>
             <a:r>
-              <a:t>AI/BI dashboards (time series + KPIs) + SQL alert on failures</a:t>
-            </a:r>
-          </a:p>
-        </p:txBody>
-      </p:sp>
+              <a:rPr sz="1300" b="0">
+                <a:solidFill>
+                  <a:srgbClr val="22262E"/>
+                </a:solidFill>
+                <a:latin typeface="Calibri"/>
+              </a:rPr>
+              <a:t>Same views on the latest NASA POWER data (2025-01 → 2026-07).</a:t>
+            </a:r>
+          </a:p>
+        </p:txBody>
+      </p:sp>
+      <p:sp>
+        <p:nvSpPr>
+          <p:cNvPr id="10" name="Rectangle 9"/>
+          <p:cNvSpPr/>
+          <p:nvPr/>
+        </p:nvSpPr>
+        <p:spPr>
+          <a:xfrm>
+            <a:off x="457200" y="3950208"/>
+            <a:ext cx="164592" cy="960120"/>
+          </a:xfrm>
+          <a:prstGeom prst="rect">
+            <a:avLst/>
+          </a:prstGeom>
+          <a:solidFill>
+            <a:srgbClr val="2E5BA8"/>
+          </a:solidFill>
+          <a:ln>
+            <a:noFill/>
+          </a:ln>
+          <a:effectLst/>
+        </p:spPr>
+        <p:style>
+          <a:lnRef idx="1">
+            <a:schemeClr val="accent1"/>
+          </a:lnRef>
+          <a:fillRef idx="3">
+            <a:schemeClr val="accent1"/>
+          </a:fillRef>
+          <a:effectRef idx="2">
+            <a:schemeClr val="accent1"/>
+          </a:effectRef>
+          <a:fontRef idx="minor">
+            <a:schemeClr val="lt1"/>
+          </a:fontRef>
+        </p:style>
+        <p:txBody>
+          <a:bodyPr rtlCol="0" anchor="ctr"/>
+          <a:lstStyle/>
+          <a:p>
+            <a:pPr algn="ctr"/>
+          </a:p>
+        </p:txBody>
+      </p:sp>
+      <p:sp>
+        <p:nvSpPr>
+          <p:cNvPr id="11" name="TextBox 10"/>
+          <p:cNvSpPr txBox="1"/>
+          <p:nvPr/>
+        </p:nvSpPr>
+        <p:spPr>
+          <a:xfrm>
+            <a:off x="777240" y="3877056"/>
+            <a:ext cx="10972800" cy="457200"/>
+          </a:xfrm>
+          <a:prstGeom prst="rect">
+            <a:avLst/>
+          </a:prstGeom>
+          <a:noFill/>
+        </p:spPr>
+        <p:txBody>
+          <a:bodyPr wrap="square">
+            <a:spAutoFit/>
+          </a:bodyPr>
+          <a:lstStyle/>
+          <a:p>
+            <a:pPr algn="l">
+              <a:spcAft>
+                <a:spcPts val="400"/>
+              </a:spcAft>
+            </a:pPr>
+            <a:r>
+              <a:rPr sz="1600" b="1">
+                <a:solidFill>
+                  <a:srgbClr val="1B2A4A"/>
+                </a:solidFill>
+                <a:latin typeface="Calibri"/>
+              </a:rPr>
+              <a:t>Weather NASA (time series + KPIs)</a:t>
+            </a:r>
+          </a:p>
+        </p:txBody>
+      </p:sp>
+      <p:sp>
+        <p:nvSpPr>
+          <p:cNvPr id="12" name="TextBox 11"/>
+          <p:cNvSpPr txBox="1"/>
+          <p:nvPr/>
+        </p:nvSpPr>
+        <p:spPr>
+          <a:xfrm>
+            <a:off x="777240" y="4261104"/>
+            <a:ext cx="10972800" cy="640080"/>
+          </a:xfrm>
+          <a:prstGeom prst="rect">
+            <a:avLst/>
+          </a:prstGeom>
+          <a:noFill/>
+        </p:spPr>
+        <p:txBody>
+          <a:bodyPr wrap="square">
+            <a:spAutoFit/>
+          </a:bodyPr>
+          <a:lstStyle/>
+          <a:p>
+            <a:pPr algn="l">
+              <a:spcAft>
+                <a:spcPts val="400"/>
+              </a:spcAft>
+            </a:pPr>
+            <a:r>
+              <a:rPr sz="1300" b="0">
+                <a:solidFill>
+                  <a:srgbClr val="22262E"/>
+                </a:solidFill>
+                <a:latin typeface="Calibri"/>
+              </a:rPr>
+              <a:t>Monthly GHI/wind per plant + resource-KPI table (rank, A/B/C tier).</a:t>
+            </a:r>
+          </a:p>
+        </p:txBody>
+      </p:sp>
+      <p:sp>
+        <p:nvSpPr>
+          <p:cNvPr id="13" name="Rectangle 12"/>
+          <p:cNvSpPr/>
+          <p:nvPr/>
+        </p:nvSpPr>
+        <p:spPr>
+          <a:xfrm>
+            <a:off x="457200" y="5157216"/>
+            <a:ext cx="164592" cy="960120"/>
+          </a:xfrm>
+          <a:prstGeom prst="rect">
+            <a:avLst/>
+          </a:prstGeom>
+          <a:solidFill>
+            <a:srgbClr val="2E5BA8"/>
+          </a:solidFill>
+          <a:ln>
+            <a:noFill/>
+          </a:ln>
+          <a:effectLst/>
+        </p:spPr>
+        <p:style>
+          <a:lnRef idx="1">
+            <a:schemeClr val="accent1"/>
+          </a:lnRef>
+          <a:fillRef idx="3">
+            <a:schemeClr val="accent1"/>
+          </a:fillRef>
+          <a:effectRef idx="2">
+            <a:schemeClr val="accent1"/>
+          </a:effectRef>
+          <a:fontRef idx="minor">
+            <a:schemeClr val="lt1"/>
+          </a:fontRef>
+        </p:style>
+        <p:txBody>
+          <a:bodyPr rtlCol="0" anchor="ctr"/>
+          <a:lstStyle/>
+          <a:p>
+            <a:pPr algn="ctr"/>
+          </a:p>
+        </p:txBody>
+      </p:sp>
+      <p:sp>
+        <p:nvSpPr>
+          <p:cNvPr id="14" name="TextBox 13"/>
+          <p:cNvSpPr txBox="1"/>
+          <p:nvPr/>
+        </p:nvSpPr>
+        <p:spPr>
+          <a:xfrm>
+            <a:off x="777240" y="5084064"/>
+            <a:ext cx="10972800" cy="457200"/>
+          </a:xfrm>
+          <a:prstGeom prst="rect">
+            <a:avLst/>
+          </a:prstGeom>
+          <a:noFill/>
+        </p:spPr>
+        <p:txBody>
+          <a:bodyPr wrap="square">
+            <a:spAutoFit/>
+          </a:bodyPr>
+          <a:lstStyle/>
+          <a:p>
+            <a:pPr algn="l">
+              <a:spcAft>
+                <a:spcPts val="400"/>
+              </a:spcAft>
+            </a:pPr>
+            <a:r>
+              <a:rPr sz="1600" b="1">
+                <a:solidFill>
+                  <a:srgbClr val="1B2A4A"/>
+                </a:solidFill>
+                <a:latin typeface="Calibri"/>
+              </a:rPr>
+              <a:t>3 Data-Quality Monitors + SQL alert</a:t>
+            </a:r>
+          </a:p>
+        </p:txBody>
+      </p:sp>
+      <p:sp>
+        <p:nvSpPr>
+          <p:cNvPr id="15" name="TextBox 14"/>
+          <p:cNvSpPr txBox="1"/>
+          <p:nvPr/>
+        </p:nvSpPr>
+        <p:spPr>
+          <a:xfrm>
+            <a:off x="777240" y="5468112"/>
+            <a:ext cx="10972800" cy="640080"/>
+          </a:xfrm>
+          <a:prstGeom prst="rect">
+            <a:avLst/>
+          </a:prstGeom>
+          <a:noFill/>
+        </p:spPr>
+        <p:txBody>
+          <a:bodyPr wrap="square">
+            <a:spAutoFit/>
+          </a:bodyPr>
+          <a:lstStyle/>
+          <a:p>
+            <a:pPr algn="l">
+              <a:spcAft>
+                <a:spcPts val="400"/>
+              </a:spcAft>
+            </a:pPr>
+            <a:r>
+              <a:rPr sz="1300" b="0">
+                <a:solidFill>
+                  <a:srgbClr val="22262E"/>
+                </a:solidFill>
+                <a:latin typeface="Calibri"/>
+              </a:rPr>
+              <a:t>Profiling + drift on gold, per domain, auto-generated dashboards.</a:t>
+            </a:r>
+          </a:p>
+        </p:txBody>
+      </p:sp>
+    </p:spTree>
+  </p:cSld>
+  <p:clrMapOvr>
+    <a:masterClrMapping/>
+  </p:clrMapOvr>
+</p:sld>
+</file>
+
+<file path=ppt/slides/slide8.xml><?xml version="1.0" encoding="utf-8"?>
+<p:sld xmlns:a="http://schemas.openxmlformats.org/drawingml/2006/main" xmlns:p="http://schemas.openxmlformats.org/presentationml/2006/main" xmlns:r="http://schemas.openxmlformats.org/officeDocument/2006/relationships">
+  <p:cSld>
+    <p:spTree>
+      <p:nvGrpSpPr>
+        <p:cNvPr id="1" name=""/>
+        <p:cNvGrpSpPr/>
+        <p:nvPr/>
+      </p:nvGrpSpPr>
+      <p:grpSpPr/>
+      <p:sp>
+        <p:nvSpPr>
+          <p:cNvPr id="2" name="Rectangle 1"/>
+          <p:cNvSpPr/>
+          <p:nvPr/>
+        </p:nvSpPr>
+        <p:spPr>
+          <a:xfrm>
+            <a:off x="0" y="0"/>
+            <a:ext cx="12191695" cy="1051560"/>
+          </a:xfrm>
+          <a:prstGeom prst="rect">
+            <a:avLst/>
+          </a:prstGeom>
+          <a:solidFill>
+            <a:srgbClr val="1B2A4A"/>
+          </a:solidFill>
+          <a:ln>
+            <a:noFill/>
+          </a:ln>
+          <a:effectLst/>
+        </p:spPr>
+        <p:style>
+          <a:lnRef idx="1">
+            <a:schemeClr val="accent1"/>
+          </a:lnRef>
+          <a:fillRef idx="3">
+            <a:schemeClr val="accent1"/>
+          </a:fillRef>
+          <a:effectRef idx="2">
+            <a:schemeClr val="accent1"/>
+          </a:effectRef>
+          <a:fontRef idx="minor">
+            <a:schemeClr val="lt1"/>
+          </a:fontRef>
+        </p:style>
+        <p:txBody>
+          <a:bodyPr rtlCol="0" anchor="ctr"/>
+          <a:lstStyle/>
+          <a:p>
+            <a:pPr algn="ctr"/>
+          </a:p>
+        </p:txBody>
+      </p:sp>
+      <p:sp>
+        <p:nvSpPr>
+          <p:cNvPr id="3" name="TextBox 2"/>
+          <p:cNvSpPr txBox="1"/>
+          <p:nvPr/>
+        </p:nvSpPr>
+        <p:spPr>
+          <a:xfrm>
+            <a:off x="457200" y="164592"/>
+            <a:ext cx="11247120" cy="731520"/>
+          </a:xfrm>
+          <a:prstGeom prst="rect">
+            <a:avLst/>
+          </a:prstGeom>
+          <a:noFill/>
+        </p:spPr>
+        <p:txBody>
+          <a:bodyPr wrap="square">
+            <a:spAutoFit/>
+          </a:bodyPr>
+          <a:lstStyle/>
+          <a:p>
+            <a:pPr algn="l">
+              <a:spcAft>
+                <a:spcPts val="400"/>
+              </a:spcAft>
+            </a:pPr>
+            <a:r>
+              <a:rPr sz="2600" b="1">
+                <a:solidFill>
+                  <a:srgbClr val="FFFFFF"/>
+                </a:solidFill>
+                <a:latin typeface="Calibri"/>
+              </a:rPr>
+              <a:t>Dashboard — Chile tab</a:t>
+            </a:r>
+          </a:p>
+        </p:txBody>
+      </p:sp>
+      <p:sp>
+        <p:nvSpPr>
+          <p:cNvPr id="4" name="TextBox 3"/>
+          <p:cNvSpPr txBox="1"/>
+          <p:nvPr/>
+        </p:nvSpPr>
+        <p:spPr>
+          <a:xfrm>
+            <a:off x="457200" y="658368"/>
+            <a:ext cx="11247120" cy="365760"/>
+          </a:xfrm>
+          <a:prstGeom prst="rect">
+            <a:avLst/>
+          </a:prstGeom>
+          <a:noFill/>
+        </p:spPr>
+        <p:txBody>
+          <a:bodyPr wrap="square">
+            <a:spAutoFit/>
+          </a:bodyPr>
+          <a:lstStyle/>
+          <a:p>
+            <a:pPr algn="l">
+              <a:spcAft>
+                <a:spcPts val="400"/>
+              </a:spcAft>
+            </a:pPr>
+            <a:r>
+              <a:rPr sz="1200" b="0">
+                <a:solidFill>
+                  <a:srgbClr val="C7D2E6"/>
+                </a:solidFill>
+                <a:latin typeface="Calibri"/>
+              </a:rPr>
+              <a:t>Seasonality &amp; trends · rendered from dev.weather_silver.all_sources</a:t>
+            </a:r>
+          </a:p>
+        </p:txBody>
+      </p:sp>
+      <p:pic>
+        <p:nvPicPr>
+          <p:cNvPr id="5" name="Picture 4" descr="dashboard-chile.png"/>
+          <p:cNvPicPr>
+            <a:picLocks noChangeAspect="1"/>
+          </p:cNvPicPr>
+          <p:nvPr/>
+        </p:nvPicPr>
+        <p:blipFill>
+          <a:blip r:embed="rId2"/>
+          <a:stretch>
+            <a:fillRect/>
+          </a:stretch>
+        </p:blipFill>
+        <p:spPr>
+          <a:xfrm>
+            <a:off x="914400" y="1280160"/>
+            <a:ext cx="10332720" cy="6674349"/>
+          </a:xfrm>
+          <a:prstGeom prst="rect">
+            <a:avLst/>
+          </a:prstGeom>
+        </p:spPr>
+      </p:pic>
+    </p:spTree>
+  </p:cSld>
+  <p:clrMapOvr>
+    <a:masterClrMapping/>
+  </p:clrMapOvr>
+</p:sld>
+</file>
+
+<file path=ppt/slides/slide9.xml><?xml version="1.0" encoding="utf-8"?>
+<p:sld xmlns:a="http://schemas.openxmlformats.org/drawingml/2006/main" xmlns:p="http://schemas.openxmlformats.org/presentationml/2006/main" xmlns:r="http://schemas.openxmlformats.org/officeDocument/2006/relationships">
+  <p:cSld>
+    <p:spTree>
+      <p:nvGrpSpPr>
+        <p:cNvPr id="1" name=""/>
+        <p:cNvGrpSpPr/>
+        <p:nvPr/>
+      </p:nvGrpSpPr>
+      <p:grpSpPr/>
+      <p:sp>
+        <p:nvSpPr>
+          <p:cNvPr id="2" name="Rectangle 1"/>
+          <p:cNvSpPr/>
+          <p:nvPr/>
+        </p:nvSpPr>
+        <p:spPr>
+          <a:xfrm>
+            <a:off x="0" y="0"/>
+            <a:ext cx="12191695" cy="1051560"/>
+          </a:xfrm>
+          <a:prstGeom prst="rect">
+            <a:avLst/>
+          </a:prstGeom>
+          <a:solidFill>
+            <a:srgbClr val="1B2A4A"/>
+          </a:solidFill>
+          <a:ln>
+            <a:noFill/>
+          </a:ln>
+          <a:effectLst/>
+        </p:spPr>
+        <p:style>
+          <a:lnRef idx="1">
+            <a:schemeClr val="accent1"/>
+          </a:lnRef>
+          <a:fillRef idx="3">
+            <a:schemeClr val="accent1"/>
+          </a:fillRef>
+          <a:effectRef idx="2">
+            <a:schemeClr val="accent1"/>
+          </a:effectRef>
+          <a:fontRef idx="minor">
+            <a:schemeClr val="lt1"/>
+          </a:fontRef>
+        </p:style>
+        <p:txBody>
+          <a:bodyPr rtlCol="0" anchor="ctr"/>
+          <a:lstStyle/>
+          <a:p>
+            <a:pPr algn="ctr"/>
+          </a:p>
+        </p:txBody>
+      </p:sp>
+      <p:sp>
+        <p:nvSpPr>
+          <p:cNvPr id="3" name="TextBox 2"/>
+          <p:cNvSpPr txBox="1"/>
+          <p:nvPr/>
+        </p:nvSpPr>
+        <p:spPr>
+          <a:xfrm>
+            <a:off x="457200" y="164592"/>
+            <a:ext cx="11247120" cy="731520"/>
+          </a:xfrm>
+          <a:prstGeom prst="rect">
+            <a:avLst/>
+          </a:prstGeom>
+          <a:noFill/>
+        </p:spPr>
+        <p:txBody>
+          <a:bodyPr wrap="square">
+            <a:spAutoFit/>
+          </a:bodyPr>
+          <a:lstStyle/>
+          <a:p>
+            <a:pPr algn="l">
+              <a:spcAft>
+                <a:spcPts val="400"/>
+              </a:spcAft>
+            </a:pPr>
+            <a:r>
+              <a:rPr sz="2600" b="1">
+                <a:solidFill>
+                  <a:srgbClr val="FFFFFF"/>
+                </a:solidFill>
+                <a:latin typeface="Calibri"/>
+              </a:rPr>
+              <a:t>Dashboard — Rest of World tab</a:t>
+            </a:r>
+          </a:p>
+        </p:txBody>
+      </p:sp>
+      <p:sp>
+        <p:nvSpPr>
+          <p:cNvPr id="4" name="TextBox 3"/>
+          <p:cNvSpPr txBox="1"/>
+          <p:nvPr/>
+        </p:nvSpPr>
+        <p:spPr>
+          <a:xfrm>
+            <a:off x="457200" y="658368"/>
+            <a:ext cx="11247120" cy="365760"/>
+          </a:xfrm>
+          <a:prstGeom prst="rect">
+            <a:avLst/>
+          </a:prstGeom>
+          <a:noFill/>
+        </p:spPr>
+        <p:txBody>
+          <a:bodyPr wrap="square">
+            <a:spAutoFit/>
+          </a:bodyPr>
+          <a:lstStyle/>
+          <a:p>
+            <a:pPr algn="l">
+              <a:spcAft>
+                <a:spcPts val="400"/>
+              </a:spcAft>
+            </a:pPr>
+            <a:r>
+              <a:rPr sz="1200" b="0">
+                <a:solidFill>
+                  <a:srgbClr val="C7D2E6"/>
+                </a:solidFill>
+                <a:latin typeface="Calibri"/>
+              </a:rPr>
+              <a:t>Hemisphere seasonality · 12 cities · dev.weather_gold.world_daily_2023_2024</a:t>
+            </a:r>
+          </a:p>
+        </p:txBody>
+      </p:sp>
+      <p:pic>
+        <p:nvPicPr>
+          <p:cNvPr id="5" name="Picture 4" descr="dashboard-world.png"/>
+          <p:cNvPicPr>
+            <a:picLocks noChangeAspect="1"/>
+          </p:cNvPicPr>
+          <p:nvPr/>
+        </p:nvPicPr>
+        <p:blipFill>
+          <a:blip r:embed="rId2"/>
+          <a:stretch>
+            <a:fillRect/>
+          </a:stretch>
+        </p:blipFill>
+        <p:spPr>
+          <a:xfrm>
+            <a:off x="914400" y="1280160"/>
+            <a:ext cx="10332720" cy="6603577"/>
+          </a:xfrm>
+          <a:prstGeom prst="rect">
+            <a:avLst/>
+          </a:prstGeom>
+        </p:spPr>
+      </p:pic>
     </p:spTree>
   </p:cSld>
   <p:clrMapOvr>

</xml_diff>